<commit_message>
idk what this is
</commit_message>
<xml_diff>
--- a/Project1/figures for project.pptx
+++ b/Project1/figures for project.pptx
@@ -107,13 +107,18 @@
       </a:defRPr>
     </a:lvl9pPr>
   </p:defaultTextStyle>
+  <p:extLst>
+    <p:ext uri="{EFAFB233-063F-42B5-8137-9DF3F51BA10A}">
+      <p15:sldGuideLst xmlns:p15="http://schemas.microsoft.com/office/powerpoint/2012/main"/>
+    </p:ext>
+  </p:extLst>
 </p:presentation>
 </file>
 
 <file path=ppt/revisionInfo.xml><?xml version="1.0" encoding="utf-8"?>
 <p1510:revInfo xmlns:a="http://schemas.openxmlformats.org/drawingml/2006/main" xmlns:r="http://schemas.openxmlformats.org/officeDocument/2006/relationships" xmlns:p1510="http://schemas.microsoft.com/office/powerpoint/2015/10/main">
   <p1510:revLst>
-    <p1510:client id="{DDD189C0-1C4C-4612-B1F3-0678A6B8716E}" v="38" dt="2026-05-05T11:50:27.217"/>
+    <p1510:client id="{DDD189C0-1C4C-4612-B1F3-0678A6B8716E}" v="7" dt="2026-05-14T11:23:45.094"/>
   </p1510:revLst>
 </p1510:revInfo>
 </file>
@@ -123,34 +128,18 @@
   <pc:docChgLst>
     <pc:chgData name="Malte Hansen" userId="e2fbc9eb-1f72-4e56-aacd-c5bbbe39b840" providerId="ADAL" clId="{A2F0E014-A1BD-493F-914B-9F6C0B0FEA44}"/>
     <pc:docChg chg="undo custSel modSld">
-      <pc:chgData name="Malte Hansen" userId="e2fbc9eb-1f72-4e56-aacd-c5bbbe39b840" providerId="ADAL" clId="{A2F0E014-A1BD-493F-914B-9F6C0B0FEA44}" dt="2026-05-05T11:50:45.368" v="581" actId="13822"/>
+      <pc:chgData name="Malte Hansen" userId="e2fbc9eb-1f72-4e56-aacd-c5bbbe39b840" providerId="ADAL" clId="{A2F0E014-A1BD-493F-914B-9F6C0B0FEA44}" dt="2026-05-14T11:23:45.094" v="619" actId="164"/>
       <pc:docMkLst>
         <pc:docMk/>
       </pc:docMkLst>
       <pc:sldChg chg="addSp delSp modSp mod">
-        <pc:chgData name="Malte Hansen" userId="e2fbc9eb-1f72-4e56-aacd-c5bbbe39b840" providerId="ADAL" clId="{A2F0E014-A1BD-493F-914B-9F6C0B0FEA44}" dt="2026-05-05T11:50:45.368" v="581" actId="13822"/>
+        <pc:chgData name="Malte Hansen" userId="e2fbc9eb-1f72-4e56-aacd-c5bbbe39b840" providerId="ADAL" clId="{A2F0E014-A1BD-493F-914B-9F6C0B0FEA44}" dt="2026-05-14T11:23:45.094" v="619" actId="164"/>
         <pc:sldMkLst>
           <pc:docMk/>
           <pc:sldMk cId="1913651356" sldId="256"/>
         </pc:sldMkLst>
-        <pc:spChg chg="del">
-          <ac:chgData name="Malte Hansen" userId="e2fbc9eb-1f72-4e56-aacd-c5bbbe39b840" providerId="ADAL" clId="{A2F0E014-A1BD-493F-914B-9F6C0B0FEA44}" dt="2026-05-05T10:40:55.478" v="0" actId="21"/>
-          <ac:spMkLst>
-            <pc:docMk/>
-            <pc:sldMk cId="1913651356" sldId="256"/>
-            <ac:spMk id="2" creationId="{9EB15835-7A55-2A16-4514-C552564F4BCF}"/>
-          </ac:spMkLst>
-        </pc:spChg>
-        <pc:spChg chg="del">
-          <ac:chgData name="Malte Hansen" userId="e2fbc9eb-1f72-4e56-aacd-c5bbbe39b840" providerId="ADAL" clId="{A2F0E014-A1BD-493F-914B-9F6C0B0FEA44}" dt="2026-05-05T10:40:59.696" v="1" actId="21"/>
-          <ac:spMkLst>
-            <pc:docMk/>
-            <pc:sldMk cId="1913651356" sldId="256"/>
-            <ac:spMk id="3" creationId="{013FAAA3-17F0-3EA3-02B4-2DE9C3BF156B}"/>
-          </ac:spMkLst>
-        </pc:spChg>
         <pc:spChg chg="add mod topLvl">
-          <ac:chgData name="Malte Hansen" userId="e2fbc9eb-1f72-4e56-aacd-c5bbbe39b840" providerId="ADAL" clId="{A2F0E014-A1BD-493F-914B-9F6C0B0FEA44}" dt="2026-05-05T11:46:45.467" v="540"/>
+          <ac:chgData name="Malte Hansen" userId="e2fbc9eb-1f72-4e56-aacd-c5bbbe39b840" providerId="ADAL" clId="{A2F0E014-A1BD-493F-914B-9F6C0B0FEA44}" dt="2026-05-14T11:21:10.077" v="597" actId="165"/>
           <ac:spMkLst>
             <pc:docMk/>
             <pc:sldMk cId="1913651356" sldId="256"/>
@@ -158,7 +147,7 @@
           </ac:spMkLst>
         </pc:spChg>
         <pc:spChg chg="add mod topLvl">
-          <ac:chgData name="Malte Hansen" userId="e2fbc9eb-1f72-4e56-aacd-c5bbbe39b840" providerId="ADAL" clId="{A2F0E014-A1BD-493F-914B-9F6C0B0FEA44}" dt="2026-05-05T11:45:59.676" v="534"/>
+          <ac:chgData name="Malte Hansen" userId="e2fbc9eb-1f72-4e56-aacd-c5bbbe39b840" providerId="ADAL" clId="{A2F0E014-A1BD-493F-914B-9F6C0B0FEA44}" dt="2026-05-14T11:21:10.077" v="597" actId="165"/>
           <ac:spMkLst>
             <pc:docMk/>
             <pc:sldMk cId="1913651356" sldId="256"/>
@@ -166,7 +155,7 @@
           </ac:spMkLst>
         </pc:spChg>
         <pc:spChg chg="add mod topLvl">
-          <ac:chgData name="Malte Hansen" userId="e2fbc9eb-1f72-4e56-aacd-c5bbbe39b840" providerId="ADAL" clId="{A2F0E014-A1BD-493F-914B-9F6C0B0FEA44}" dt="2026-05-05T11:46:50.041" v="542"/>
+          <ac:chgData name="Malte Hansen" userId="e2fbc9eb-1f72-4e56-aacd-c5bbbe39b840" providerId="ADAL" clId="{A2F0E014-A1BD-493F-914B-9F6C0B0FEA44}" dt="2026-05-14T11:23:45.094" v="619" actId="164"/>
           <ac:spMkLst>
             <pc:docMk/>
             <pc:sldMk cId="1913651356" sldId="256"/>
@@ -174,31 +163,15 @@
           </ac:spMkLst>
         </pc:spChg>
         <pc:spChg chg="add mod topLvl">
-          <ac:chgData name="Malte Hansen" userId="e2fbc9eb-1f72-4e56-aacd-c5bbbe39b840" providerId="ADAL" clId="{A2F0E014-A1BD-493F-914B-9F6C0B0FEA44}" dt="2026-05-05T11:26:45.032" v="416" actId="164"/>
+          <ac:chgData name="Malte Hansen" userId="e2fbc9eb-1f72-4e56-aacd-c5bbbe39b840" providerId="ADAL" clId="{A2F0E014-A1BD-493F-914B-9F6C0B0FEA44}" dt="2026-05-14T11:23:45.094" v="619" actId="164"/>
           <ac:spMkLst>
             <pc:docMk/>
             <pc:sldMk cId="1913651356" sldId="256"/>
             <ac:spMk id="7" creationId="{C5D8EAD3-B018-605A-1B0C-E2218D1A91B2}"/>
           </ac:spMkLst>
         </pc:spChg>
-        <pc:spChg chg="add del">
-          <ac:chgData name="Malte Hansen" userId="e2fbc9eb-1f72-4e56-aacd-c5bbbe39b840" providerId="ADAL" clId="{A2F0E014-A1BD-493F-914B-9F6C0B0FEA44}" dt="2026-05-05T10:49:22.457" v="29" actId="11529"/>
-          <ac:spMkLst>
-            <pc:docMk/>
-            <pc:sldMk cId="1913651356" sldId="256"/>
-            <ac:spMk id="21" creationId="{67C9DBF8-59B3-5FC6-ECB6-A525B1243708}"/>
-          </ac:spMkLst>
-        </pc:spChg>
-        <pc:spChg chg="add del mod">
-          <ac:chgData name="Malte Hansen" userId="e2fbc9eb-1f72-4e56-aacd-c5bbbe39b840" providerId="ADAL" clId="{A2F0E014-A1BD-493F-914B-9F6C0B0FEA44}" dt="2026-05-05T10:49:33.506" v="32" actId="21"/>
-          <ac:spMkLst>
-            <pc:docMk/>
-            <pc:sldMk cId="1913651356" sldId="256"/>
-            <ac:spMk id="22" creationId="{B1E735B2-69C0-94F0-4755-8774B63B8505}"/>
-          </ac:spMkLst>
-        </pc:spChg>
         <pc:spChg chg="add mod topLvl">
-          <ac:chgData name="Malte Hansen" userId="e2fbc9eb-1f72-4e56-aacd-c5bbbe39b840" providerId="ADAL" clId="{A2F0E014-A1BD-493F-914B-9F6C0B0FEA44}" dt="2026-05-05T11:46:50.041" v="542"/>
+          <ac:chgData name="Malte Hansen" userId="e2fbc9eb-1f72-4e56-aacd-c5bbbe39b840" providerId="ADAL" clId="{A2F0E014-A1BD-493F-914B-9F6C0B0FEA44}" dt="2026-05-14T11:23:45.094" v="619" actId="164"/>
           <ac:spMkLst>
             <pc:docMk/>
             <pc:sldMk cId="1913651356" sldId="256"/>
@@ -206,31 +179,15 @@
           </ac:spMkLst>
         </pc:spChg>
         <pc:spChg chg="add mod topLvl">
-          <ac:chgData name="Malte Hansen" userId="e2fbc9eb-1f72-4e56-aacd-c5bbbe39b840" providerId="ADAL" clId="{A2F0E014-A1BD-493F-914B-9F6C0B0FEA44}" dt="2026-05-05T11:46:50.041" v="542"/>
+          <ac:chgData name="Malte Hansen" userId="e2fbc9eb-1f72-4e56-aacd-c5bbbe39b840" providerId="ADAL" clId="{A2F0E014-A1BD-493F-914B-9F6C0B0FEA44}" dt="2026-05-14T11:23:45.094" v="619" actId="164"/>
           <ac:spMkLst>
             <pc:docMk/>
             <pc:sldMk cId="1913651356" sldId="256"/>
             <ac:spMk id="25" creationId="{4D832E5E-136E-5381-B4A6-510DCE1FEF0C}"/>
           </ac:spMkLst>
         </pc:spChg>
-        <pc:spChg chg="add del mod">
-          <ac:chgData name="Malte Hansen" userId="e2fbc9eb-1f72-4e56-aacd-c5bbbe39b840" providerId="ADAL" clId="{A2F0E014-A1BD-493F-914B-9F6C0B0FEA44}" dt="2026-05-05T11:01:55.321" v="173" actId="21"/>
-          <ac:spMkLst>
-            <pc:docMk/>
-            <pc:sldMk cId="1913651356" sldId="256"/>
-            <ac:spMk id="52" creationId="{C599A5F0-D7B6-681D-9F4E-251C35E44933}"/>
-          </ac:spMkLst>
-        </pc:spChg>
-        <pc:spChg chg="add del mod">
-          <ac:chgData name="Malte Hansen" userId="e2fbc9eb-1f72-4e56-aacd-c5bbbe39b840" providerId="ADAL" clId="{A2F0E014-A1BD-493F-914B-9F6C0B0FEA44}" dt="2026-05-05T11:01:35.741" v="171" actId="478"/>
-          <ac:spMkLst>
-            <pc:docMk/>
-            <pc:sldMk cId="1913651356" sldId="256"/>
-            <ac:spMk id="53" creationId="{FF2BFCB3-C6F8-FE2C-3CAA-7F0AA14E251D}"/>
-          </ac:spMkLst>
-        </pc:spChg>
         <pc:spChg chg="add mod topLvl">
-          <ac:chgData name="Malte Hansen" userId="e2fbc9eb-1f72-4e56-aacd-c5bbbe39b840" providerId="ADAL" clId="{A2F0E014-A1BD-493F-914B-9F6C0B0FEA44}" dt="2026-05-05T11:45:59.676" v="534"/>
+          <ac:chgData name="Malte Hansen" userId="e2fbc9eb-1f72-4e56-aacd-c5bbbe39b840" providerId="ADAL" clId="{A2F0E014-A1BD-493F-914B-9F6C0B0FEA44}" dt="2026-05-14T11:23:45.094" v="619" actId="164"/>
           <ac:spMkLst>
             <pc:docMk/>
             <pc:sldMk cId="1913651356" sldId="256"/>
@@ -238,63 +195,47 @@
           </ac:spMkLst>
         </pc:spChg>
         <pc:spChg chg="add mod topLvl">
-          <ac:chgData name="Malte Hansen" userId="e2fbc9eb-1f72-4e56-aacd-c5bbbe39b840" providerId="ADAL" clId="{A2F0E014-A1BD-493F-914B-9F6C0B0FEA44}" dt="2026-05-05T11:46:50.041" v="542"/>
+          <ac:chgData name="Malte Hansen" userId="e2fbc9eb-1f72-4e56-aacd-c5bbbe39b840" providerId="ADAL" clId="{A2F0E014-A1BD-493F-914B-9F6C0B0FEA44}" dt="2026-05-14T11:23:45.094" v="619" actId="164"/>
           <ac:spMkLst>
             <pc:docMk/>
             <pc:sldMk cId="1913651356" sldId="256"/>
             <ac:spMk id="111" creationId="{2D86E45E-E479-1CC8-4526-F561E796C416}"/>
           </ac:spMkLst>
         </pc:spChg>
-        <pc:spChg chg="add del mod">
-          <ac:chgData name="Malte Hansen" userId="e2fbc9eb-1f72-4e56-aacd-c5bbbe39b840" providerId="ADAL" clId="{A2F0E014-A1BD-493F-914B-9F6C0B0FEA44}" dt="2026-05-05T11:19:22.209" v="346" actId="21"/>
-          <ac:spMkLst>
-            <pc:docMk/>
-            <pc:sldMk cId="1913651356" sldId="256"/>
-            <ac:spMk id="129" creationId="{EF9D40A8-FE76-8995-A9CA-AC1139938983}"/>
-          </ac:spMkLst>
-        </pc:spChg>
-        <pc:spChg chg="add mod">
-          <ac:chgData name="Malte Hansen" userId="e2fbc9eb-1f72-4e56-aacd-c5bbbe39b840" providerId="ADAL" clId="{A2F0E014-A1BD-493F-914B-9F6C0B0FEA44}" dt="2026-05-05T11:46:50.041" v="542"/>
+        <pc:spChg chg="add mod topLvl">
+          <ac:chgData name="Malte Hansen" userId="e2fbc9eb-1f72-4e56-aacd-c5bbbe39b840" providerId="ADAL" clId="{A2F0E014-A1BD-493F-914B-9F6C0B0FEA44}" dt="2026-05-14T11:23:45.094" v="619" actId="164"/>
           <ac:spMkLst>
             <pc:docMk/>
             <pc:sldMk cId="1913651356" sldId="256"/>
             <ac:spMk id="132" creationId="{3469F32C-EAF8-74C6-BC2A-18B72550A539}"/>
           </ac:spMkLst>
         </pc:spChg>
-        <pc:spChg chg="add del mod">
-          <ac:chgData name="Malte Hansen" userId="e2fbc9eb-1f72-4e56-aacd-c5bbbe39b840" providerId="ADAL" clId="{A2F0E014-A1BD-493F-914B-9F6C0B0FEA44}" dt="2026-05-05T11:22:44.140" v="357" actId="21"/>
-          <ac:spMkLst>
-            <pc:docMk/>
-            <pc:sldMk cId="1913651356" sldId="256"/>
-            <ac:spMk id="133" creationId="{CFC999AB-EE5D-6899-0A29-8CE81BC5D395}"/>
-          </ac:spMkLst>
-        </pc:spChg>
-        <pc:spChg chg="add mod ord">
-          <ac:chgData name="Malte Hansen" userId="e2fbc9eb-1f72-4e56-aacd-c5bbbe39b840" providerId="ADAL" clId="{A2F0E014-A1BD-493F-914B-9F6C0B0FEA44}" dt="2026-05-05T11:45:59.676" v="534"/>
+        <pc:spChg chg="add mod ord topLvl">
+          <ac:chgData name="Malte Hansen" userId="e2fbc9eb-1f72-4e56-aacd-c5bbbe39b840" providerId="ADAL" clId="{A2F0E014-A1BD-493F-914B-9F6C0B0FEA44}" dt="2026-05-14T11:23:45.094" v="619" actId="164"/>
           <ac:spMkLst>
             <pc:docMk/>
             <pc:sldMk cId="1913651356" sldId="256"/>
             <ac:spMk id="134" creationId="{D0F8105A-A570-D521-28A7-7D375D73F45C}"/>
           </ac:spMkLst>
         </pc:spChg>
-        <pc:spChg chg="add mod">
-          <ac:chgData name="Malte Hansen" userId="e2fbc9eb-1f72-4e56-aacd-c5bbbe39b840" providerId="ADAL" clId="{A2F0E014-A1BD-493F-914B-9F6C0B0FEA44}" dt="2026-05-05T11:46:50.041" v="542"/>
+        <pc:spChg chg="add del mod">
+          <ac:chgData name="Malte Hansen" userId="e2fbc9eb-1f72-4e56-aacd-c5bbbe39b840" providerId="ADAL" clId="{A2F0E014-A1BD-493F-914B-9F6C0B0FEA44}" dt="2026-05-14T11:19:05.002" v="583" actId="478"/>
           <ac:spMkLst>
             <pc:docMk/>
             <pc:sldMk cId="1913651356" sldId="256"/>
             <ac:spMk id="158" creationId="{4582A449-4888-087B-10EC-E8CAACDB267C}"/>
           </ac:spMkLst>
         </pc:spChg>
-        <pc:spChg chg="add mod">
-          <ac:chgData name="Malte Hansen" userId="e2fbc9eb-1f72-4e56-aacd-c5bbbe39b840" providerId="ADAL" clId="{A2F0E014-A1BD-493F-914B-9F6C0B0FEA44}" dt="2026-05-05T11:46:32.787" v="539" actId="164"/>
+        <pc:spChg chg="add del mod">
+          <ac:chgData name="Malte Hansen" userId="e2fbc9eb-1f72-4e56-aacd-c5bbbe39b840" providerId="ADAL" clId="{A2F0E014-A1BD-493F-914B-9F6C0B0FEA44}" dt="2026-05-14T11:19:15.471" v="586" actId="478"/>
           <ac:spMkLst>
             <pc:docMk/>
             <pc:sldMk cId="1913651356" sldId="256"/>
             <ac:spMk id="159" creationId="{1ECBC63F-6461-2AAE-2A47-D0C3AE6DB577}"/>
           </ac:spMkLst>
         </pc:spChg>
-        <pc:spChg chg="add mod">
-          <ac:chgData name="Malte Hansen" userId="e2fbc9eb-1f72-4e56-aacd-c5bbbe39b840" providerId="ADAL" clId="{A2F0E014-A1BD-493F-914B-9F6C0B0FEA44}" dt="2026-05-05T11:46:32.787" v="539" actId="164"/>
+        <pc:spChg chg="add mod topLvl">
+          <ac:chgData name="Malte Hansen" userId="e2fbc9eb-1f72-4e56-aacd-c5bbbe39b840" providerId="ADAL" clId="{A2F0E014-A1BD-493F-914B-9F6C0B0FEA44}" dt="2026-05-14T11:23:45.094" v="619" actId="164"/>
           <ac:spMkLst>
             <pc:docMk/>
             <pc:sldMk cId="1913651356" sldId="256"/>
@@ -302,77 +243,53 @@
           </ac:spMkLst>
         </pc:spChg>
         <pc:spChg chg="add mod">
-          <ac:chgData name="Malte Hansen" userId="e2fbc9eb-1f72-4e56-aacd-c5bbbe39b840" providerId="ADAL" clId="{A2F0E014-A1BD-493F-914B-9F6C0B0FEA44}" dt="2026-05-05T11:46:32.787" v="539" actId="164"/>
+          <ac:chgData name="Malte Hansen" userId="e2fbc9eb-1f72-4e56-aacd-c5bbbe39b840" providerId="ADAL" clId="{A2F0E014-A1BD-493F-914B-9F6C0B0FEA44}" dt="2026-05-14T11:22:54.879" v="615" actId="1076"/>
           <ac:spMkLst>
             <pc:docMk/>
             <pc:sldMk cId="1913651356" sldId="256"/>
             <ac:spMk id="163" creationId="{BCBFEE1B-4640-C28E-E5D4-02F9564952D3}"/>
           </ac:spMkLst>
         </pc:spChg>
-        <pc:spChg chg="add mod">
-          <ac:chgData name="Malte Hansen" userId="e2fbc9eb-1f72-4e56-aacd-c5bbbe39b840" providerId="ADAL" clId="{A2F0E014-A1BD-493F-914B-9F6C0B0FEA44}" dt="2026-05-05T11:46:50.041" v="542"/>
+        <pc:spChg chg="add mod topLvl">
+          <ac:chgData name="Malte Hansen" userId="e2fbc9eb-1f72-4e56-aacd-c5bbbe39b840" providerId="ADAL" clId="{A2F0E014-A1BD-493F-914B-9F6C0B0FEA44}" dt="2026-05-14T11:23:45.094" v="619" actId="164"/>
           <ac:spMkLst>
             <pc:docMk/>
             <pc:sldMk cId="1913651356" sldId="256"/>
             <ac:spMk id="164" creationId="{0DDDC372-56D0-F733-35EE-8A8318D98F7D}"/>
           </ac:spMkLst>
         </pc:spChg>
-        <pc:spChg chg="add mod">
-          <ac:chgData name="Malte Hansen" userId="e2fbc9eb-1f72-4e56-aacd-c5bbbe39b840" providerId="ADAL" clId="{A2F0E014-A1BD-493F-914B-9F6C0B0FEA44}" dt="2026-05-05T11:50:14.279" v="578" actId="1076"/>
+        <pc:spChg chg="add del mod">
+          <ac:chgData name="Malte Hansen" userId="e2fbc9eb-1f72-4e56-aacd-c5bbbe39b840" providerId="ADAL" clId="{A2F0E014-A1BD-493F-914B-9F6C0B0FEA44}" dt="2026-05-14T11:20:34.277" v="592" actId="478"/>
           <ac:spMkLst>
             <pc:docMk/>
             <pc:sldMk cId="1913651356" sldId="256"/>
             <ac:spMk id="165" creationId="{626CA88C-7FEB-F802-78AF-2F47DF9600E9}"/>
           </ac:spMkLst>
         </pc:spChg>
-        <pc:spChg chg="add mod">
-          <ac:chgData name="Malte Hansen" userId="e2fbc9eb-1f72-4e56-aacd-c5bbbe39b840" providerId="ADAL" clId="{A2F0E014-A1BD-493F-914B-9F6C0B0FEA44}" dt="2026-05-05T11:47:18.056" v="547" actId="688"/>
+        <pc:spChg chg="add del mod">
+          <ac:chgData name="Malte Hansen" userId="e2fbc9eb-1f72-4e56-aacd-c5bbbe39b840" providerId="ADAL" clId="{A2F0E014-A1BD-493F-914B-9F6C0B0FEA44}" dt="2026-05-14T11:20:37.874" v="593" actId="478"/>
           <ac:spMkLst>
             <pc:docMk/>
             <pc:sldMk cId="1913651356" sldId="256"/>
             <ac:spMk id="166" creationId="{D3FD03BE-B787-B8A8-2212-3F9B24957F21}"/>
           </ac:spMkLst>
         </pc:spChg>
-        <pc:spChg chg="add mod">
-          <ac:chgData name="Malte Hansen" userId="e2fbc9eb-1f72-4e56-aacd-c5bbbe39b840" providerId="ADAL" clId="{A2F0E014-A1BD-493F-914B-9F6C0B0FEA44}" dt="2026-05-05T11:46:14.783" v="538"/>
-          <ac:spMkLst>
-            <pc:docMk/>
-            <pc:sldMk cId="1913651356" sldId="256"/>
-            <ac:spMk id="167" creationId="{17F4DC3B-A637-3589-6B89-23D3F9A7A91E}"/>
-          </ac:spMkLst>
-        </pc:spChg>
-        <pc:spChg chg="add mod">
-          <ac:chgData name="Malte Hansen" userId="e2fbc9eb-1f72-4e56-aacd-c5bbbe39b840" providerId="ADAL" clId="{A2F0E014-A1BD-493F-914B-9F6C0B0FEA44}" dt="2026-05-05T11:47:45.403" v="550" actId="1076"/>
+        <pc:spChg chg="add del mod">
+          <ac:chgData name="Malte Hansen" userId="e2fbc9eb-1f72-4e56-aacd-c5bbbe39b840" providerId="ADAL" clId="{A2F0E014-A1BD-493F-914B-9F6C0B0FEA44}" dt="2026-05-14T11:20:29.719" v="590" actId="478"/>
           <ac:spMkLst>
             <pc:docMk/>
             <pc:sldMk cId="1913651356" sldId="256"/>
             <ac:spMk id="169" creationId="{43F8C14B-DE60-5F27-8D29-C62774FA7151}"/>
           </ac:spMkLst>
         </pc:spChg>
-        <pc:spChg chg="add mod">
-          <ac:chgData name="Malte Hansen" userId="e2fbc9eb-1f72-4e56-aacd-c5bbbe39b840" providerId="ADAL" clId="{A2F0E014-A1BD-493F-914B-9F6C0B0FEA44}" dt="2026-05-05T11:50:21.610" v="579" actId="1076"/>
+        <pc:spChg chg="add del mod">
+          <ac:chgData name="Malte Hansen" userId="e2fbc9eb-1f72-4e56-aacd-c5bbbe39b840" providerId="ADAL" clId="{A2F0E014-A1BD-493F-914B-9F6C0B0FEA44}" dt="2026-05-14T11:20:25.189" v="589" actId="478"/>
           <ac:spMkLst>
             <pc:docMk/>
             <pc:sldMk cId="1913651356" sldId="256"/>
             <ac:spMk id="170" creationId="{85E8C84A-6AE7-4576-D472-7309B0675042}"/>
           </ac:spMkLst>
         </pc:spChg>
-        <pc:grpChg chg="add del mod topLvl">
-          <ac:chgData name="Malte Hansen" userId="e2fbc9eb-1f72-4e56-aacd-c5bbbe39b840" providerId="ADAL" clId="{A2F0E014-A1BD-493F-914B-9F6C0B0FEA44}" dt="2026-05-05T11:15:26.033" v="323" actId="165"/>
-          <ac:grpSpMkLst>
-            <pc:docMk/>
-            <pc:sldMk cId="1913651356" sldId="256"/>
-            <ac:grpSpMk id="23" creationId="{D78A730F-EDDF-8702-D72B-0D1483CCB88F}"/>
-          </ac:grpSpMkLst>
-        </pc:grpChg>
-        <pc:grpChg chg="add del mod">
-          <ac:chgData name="Malte Hansen" userId="e2fbc9eb-1f72-4e56-aacd-c5bbbe39b840" providerId="ADAL" clId="{A2F0E014-A1BD-493F-914B-9F6C0B0FEA44}" dt="2026-05-05T11:08:39.447" v="249" actId="21"/>
-          <ac:grpSpMkLst>
-            <pc:docMk/>
-            <pc:sldMk cId="1913651356" sldId="256"/>
-            <ac:grpSpMk id="51" creationId="{0364B6CE-6319-DA37-3D2A-C58EA7020052}"/>
-          </ac:grpSpMkLst>
-        </pc:grpChg>
         <pc:grpChg chg="mod">
           <ac:chgData name="Malte Hansen" userId="e2fbc9eb-1f72-4e56-aacd-c5bbbe39b840" providerId="ADAL" clId="{A2F0E014-A1BD-493F-914B-9F6C0B0FEA44}" dt="2026-05-05T11:46:32.787" v="539" actId="164"/>
           <ac:grpSpMkLst>
@@ -397,168 +314,24 @@
             <ac:grpSpMk id="190" creationId="{2F4DFEBD-3EA2-B74A-11D9-391147CC5163}"/>
           </ac:grpSpMkLst>
         </pc:grpChg>
-        <pc:cxnChg chg="add del mod">
-          <ac:chgData name="Malte Hansen" userId="e2fbc9eb-1f72-4e56-aacd-c5bbbe39b840" providerId="ADAL" clId="{A2F0E014-A1BD-493F-914B-9F6C0B0FEA44}" dt="2026-05-05T11:08:49.719" v="250" actId="21"/>
+        <pc:cxnChg chg="add mod">
+          <ac:chgData name="Malte Hansen" userId="e2fbc9eb-1f72-4e56-aacd-c5bbbe39b840" providerId="ADAL" clId="{A2F0E014-A1BD-493F-914B-9F6C0B0FEA44}" dt="2026-05-14T11:23:34.374" v="618" actId="14100"/>
           <ac:cxnSpMkLst>
             <pc:docMk/>
             <pc:sldMk cId="1913651356" sldId="256"/>
-            <ac:cxnSpMk id="9" creationId="{C4EBE703-BA87-A631-5469-2803F2C2DA17}"/>
+            <ac:cxnSpMk id="8" creationId="{5E742A62-47A6-B777-AB6C-19C7AB104E93}"/>
           </ac:cxnSpMkLst>
         </pc:cxnChg>
-        <pc:cxnChg chg="add del mod">
-          <ac:chgData name="Malte Hansen" userId="e2fbc9eb-1f72-4e56-aacd-c5bbbe39b840" providerId="ADAL" clId="{A2F0E014-A1BD-493F-914B-9F6C0B0FEA44}" dt="2026-05-05T10:43:42.861" v="17" actId="11529"/>
+        <pc:cxnChg chg="add mod">
+          <ac:chgData name="Malte Hansen" userId="e2fbc9eb-1f72-4e56-aacd-c5bbbe39b840" providerId="ADAL" clId="{A2F0E014-A1BD-493F-914B-9F6C0B0FEA44}" dt="2026-05-14T11:23:27.926" v="617" actId="14100"/>
           <ac:cxnSpMkLst>
             <pc:docMk/>
             <pc:sldMk cId="1913651356" sldId="256"/>
-            <ac:cxnSpMk id="11" creationId="{35F5540F-998D-4880-C60A-DE78CFC2BB79}"/>
-          </ac:cxnSpMkLst>
-        </pc:cxnChg>
-        <pc:cxnChg chg="add del mod">
-          <ac:chgData name="Malte Hansen" userId="e2fbc9eb-1f72-4e56-aacd-c5bbbe39b840" providerId="ADAL" clId="{A2F0E014-A1BD-493F-914B-9F6C0B0FEA44}" dt="2026-05-05T11:08:29.368" v="244" actId="21"/>
-          <ac:cxnSpMkLst>
-            <pc:docMk/>
-            <pc:sldMk cId="1913651356" sldId="256"/>
-            <ac:cxnSpMk id="13" creationId="{D8C6067B-4A01-834D-48D4-2A12E65CD9C5}"/>
-          </ac:cxnSpMkLst>
-        </pc:cxnChg>
-        <pc:cxnChg chg="add del mod">
-          <ac:chgData name="Malte Hansen" userId="e2fbc9eb-1f72-4e56-aacd-c5bbbe39b840" providerId="ADAL" clId="{A2F0E014-A1BD-493F-914B-9F6C0B0FEA44}" dt="2026-05-05T10:44:15.412" v="21" actId="21"/>
-          <ac:cxnSpMkLst>
-            <pc:docMk/>
-            <pc:sldMk cId="1913651356" sldId="256"/>
-            <ac:cxnSpMk id="14" creationId="{4A41C29E-8926-02AF-99F2-BBDEB49EB106}"/>
-          </ac:cxnSpMkLst>
-        </pc:cxnChg>
-        <pc:cxnChg chg="add del mod">
-          <ac:chgData name="Malte Hansen" userId="e2fbc9eb-1f72-4e56-aacd-c5bbbe39b840" providerId="ADAL" clId="{A2F0E014-A1BD-493F-914B-9F6C0B0FEA44}" dt="2026-05-05T11:08:33.725" v="246" actId="21"/>
-          <ac:cxnSpMkLst>
-            <pc:docMk/>
-            <pc:sldMk cId="1913651356" sldId="256"/>
-            <ac:cxnSpMk id="16" creationId="{0FDC4890-06AD-A37C-CF84-2D0646C89900}"/>
-          </ac:cxnSpMkLst>
-        </pc:cxnChg>
-        <pc:cxnChg chg="add del mod">
-          <ac:chgData name="Malte Hansen" userId="e2fbc9eb-1f72-4e56-aacd-c5bbbe39b840" providerId="ADAL" clId="{A2F0E014-A1BD-493F-914B-9F6C0B0FEA44}" dt="2026-05-05T11:08:35.707" v="247" actId="21"/>
-          <ac:cxnSpMkLst>
-            <pc:docMk/>
-            <pc:sldMk cId="1913651356" sldId="256"/>
-            <ac:cxnSpMk id="18" creationId="{E01246BF-703C-D928-7CBB-C8AE79E57A07}"/>
-          </ac:cxnSpMkLst>
-        </pc:cxnChg>
-        <pc:cxnChg chg="add del">
-          <ac:chgData name="Malte Hansen" userId="e2fbc9eb-1f72-4e56-aacd-c5bbbe39b840" providerId="ADAL" clId="{A2F0E014-A1BD-493F-914B-9F6C0B0FEA44}" dt="2026-05-05T10:51:16.438" v="44" actId="11529"/>
-          <ac:cxnSpMkLst>
-            <pc:docMk/>
-            <pc:sldMk cId="1913651356" sldId="256"/>
-            <ac:cxnSpMk id="27" creationId="{670DC784-1D0F-1B6E-052E-E99770747BC1}"/>
-          </ac:cxnSpMkLst>
-        </pc:cxnChg>
-        <pc:cxnChg chg="add del mod">
-          <ac:chgData name="Malte Hansen" userId="e2fbc9eb-1f72-4e56-aacd-c5bbbe39b840" providerId="ADAL" clId="{A2F0E014-A1BD-493F-914B-9F6C0B0FEA44}" dt="2026-05-05T11:08:37.515" v="248" actId="21"/>
-          <ac:cxnSpMkLst>
-            <pc:docMk/>
-            <pc:sldMk cId="1913651356" sldId="256"/>
-            <ac:cxnSpMk id="33" creationId="{85D79D36-63C9-6ADC-4F23-18AC659E3277}"/>
-          </ac:cxnSpMkLst>
-        </pc:cxnChg>
-        <pc:cxnChg chg="add del mod">
-          <ac:chgData name="Malte Hansen" userId="e2fbc9eb-1f72-4e56-aacd-c5bbbe39b840" providerId="ADAL" clId="{A2F0E014-A1BD-493F-914B-9F6C0B0FEA44}" dt="2026-05-05T10:52:20.164" v="52" actId="21"/>
-          <ac:cxnSpMkLst>
-            <pc:docMk/>
-            <pc:sldMk cId="1913651356" sldId="256"/>
-            <ac:cxnSpMk id="36" creationId="{3C5EFA33-A3F6-4DE3-2F18-B9E8133E5C4D}"/>
-          </ac:cxnSpMkLst>
-        </pc:cxnChg>
-        <pc:cxnChg chg="add del mod">
-          <ac:chgData name="Malte Hansen" userId="e2fbc9eb-1f72-4e56-aacd-c5bbbe39b840" providerId="ADAL" clId="{A2F0E014-A1BD-493F-914B-9F6C0B0FEA44}" dt="2026-05-05T10:52:34.888" v="54" actId="11529"/>
-          <ac:cxnSpMkLst>
-            <pc:docMk/>
-            <pc:sldMk cId="1913651356" sldId="256"/>
-            <ac:cxnSpMk id="38" creationId="{3F68E01D-EA9C-A58B-61D7-3E1810EC415F}"/>
-          </ac:cxnSpMkLst>
-        </pc:cxnChg>
-        <pc:cxnChg chg="add del mod topLvl">
-          <ac:chgData name="Malte Hansen" userId="e2fbc9eb-1f72-4e56-aacd-c5bbbe39b840" providerId="ADAL" clId="{A2F0E014-A1BD-493F-914B-9F6C0B0FEA44}" dt="2026-05-05T11:08:39.447" v="249" actId="21"/>
-          <ac:cxnSpMkLst>
-            <pc:docMk/>
-            <pc:sldMk cId="1913651356" sldId="256"/>
-            <ac:cxnSpMk id="40" creationId="{E0949370-ECFB-25A2-4415-FA359DC158B5}"/>
-          </ac:cxnSpMkLst>
-        </pc:cxnChg>
-        <pc:cxnChg chg="add del mod">
-          <ac:chgData name="Malte Hansen" userId="e2fbc9eb-1f72-4e56-aacd-c5bbbe39b840" providerId="ADAL" clId="{A2F0E014-A1BD-493F-914B-9F6C0B0FEA44}" dt="2026-05-05T11:08:32.017" v="245" actId="21"/>
-          <ac:cxnSpMkLst>
-            <pc:docMk/>
-            <pc:sldMk cId="1913651356" sldId="256"/>
-            <ac:cxnSpMk id="42" creationId="{94AEF1F8-0928-E02F-D557-54B6DEC10740}"/>
-          </ac:cxnSpMkLst>
-        </pc:cxnChg>
-        <pc:cxnChg chg="add del mod">
-          <ac:chgData name="Malte Hansen" userId="e2fbc9eb-1f72-4e56-aacd-c5bbbe39b840" providerId="ADAL" clId="{A2F0E014-A1BD-493F-914B-9F6C0B0FEA44}" dt="2026-05-05T11:08:25.611" v="241" actId="21"/>
-          <ac:cxnSpMkLst>
-            <pc:docMk/>
-            <pc:sldMk cId="1913651356" sldId="256"/>
-            <ac:cxnSpMk id="44" creationId="{6E04FE43-4EFA-8E4B-1DFD-4824F9F4F05C}"/>
-          </ac:cxnSpMkLst>
-        </pc:cxnChg>
-        <pc:cxnChg chg="add del mod">
-          <ac:chgData name="Malte Hansen" userId="e2fbc9eb-1f72-4e56-aacd-c5bbbe39b840" providerId="ADAL" clId="{A2F0E014-A1BD-493F-914B-9F6C0B0FEA44}" dt="2026-05-05T11:08:21.392" v="237" actId="11529"/>
-          <ac:cxnSpMkLst>
-            <pc:docMk/>
-            <pc:sldMk cId="1913651356" sldId="256"/>
-            <ac:cxnSpMk id="63" creationId="{254870EF-A217-59D2-3248-8AEB4FD13034}"/>
-          </ac:cxnSpMkLst>
-        </pc:cxnChg>
-        <pc:cxnChg chg="add del mod">
-          <ac:chgData name="Malte Hansen" userId="e2fbc9eb-1f72-4e56-aacd-c5bbbe39b840" providerId="ADAL" clId="{A2F0E014-A1BD-493F-914B-9F6C0B0FEA44}" dt="2026-05-05T11:07:15.925" v="219" actId="11529"/>
-          <ac:cxnSpMkLst>
-            <pc:docMk/>
-            <pc:sldMk cId="1913651356" sldId="256"/>
-            <ac:cxnSpMk id="66" creationId="{4DB0E5EB-C8C0-FF05-3BDC-6CD8310018EB}"/>
-          </ac:cxnSpMkLst>
-        </pc:cxnChg>
-        <pc:cxnChg chg="add del mod">
-          <ac:chgData name="Malte Hansen" userId="e2fbc9eb-1f72-4e56-aacd-c5bbbe39b840" providerId="ADAL" clId="{A2F0E014-A1BD-493F-914B-9F6C0B0FEA44}" dt="2026-05-05T11:05:32.071" v="202" actId="11529"/>
-          <ac:cxnSpMkLst>
-            <pc:docMk/>
-            <pc:sldMk cId="1913651356" sldId="256"/>
-            <ac:cxnSpMk id="70" creationId="{FA298F1E-9280-B227-5E6D-22F11187F331}"/>
-          </ac:cxnSpMkLst>
-        </pc:cxnChg>
-        <pc:cxnChg chg="add del mod">
-          <ac:chgData name="Malte Hansen" userId="e2fbc9eb-1f72-4e56-aacd-c5bbbe39b840" providerId="ADAL" clId="{A2F0E014-A1BD-493F-914B-9F6C0B0FEA44}" dt="2026-05-05T11:05:57.053" v="206" actId="11529"/>
-          <ac:cxnSpMkLst>
-            <pc:docMk/>
-            <pc:sldMk cId="1913651356" sldId="256"/>
-            <ac:cxnSpMk id="72" creationId="{FE729733-9D86-352A-C21B-10F13C80C176}"/>
-          </ac:cxnSpMkLst>
-        </pc:cxnChg>
-        <pc:cxnChg chg="add del mod">
-          <ac:chgData name="Malte Hansen" userId="e2fbc9eb-1f72-4e56-aacd-c5bbbe39b840" providerId="ADAL" clId="{A2F0E014-A1BD-493F-914B-9F6C0B0FEA44}" dt="2026-05-05T11:06:11.132" v="208" actId="11529"/>
-          <ac:cxnSpMkLst>
-            <pc:docMk/>
-            <pc:sldMk cId="1913651356" sldId="256"/>
-            <ac:cxnSpMk id="75" creationId="{0E819C60-2913-9A02-B477-62BD221E0099}"/>
-          </ac:cxnSpMkLst>
-        </pc:cxnChg>
-        <pc:cxnChg chg="add del mod">
-          <ac:chgData name="Malte Hansen" userId="e2fbc9eb-1f72-4e56-aacd-c5bbbe39b840" providerId="ADAL" clId="{A2F0E014-A1BD-493F-914B-9F6C0B0FEA44}" dt="2026-05-05T11:07:14.244" v="216" actId="11529"/>
-          <ac:cxnSpMkLst>
-            <pc:docMk/>
-            <pc:sldMk cId="1913651356" sldId="256"/>
-            <ac:cxnSpMk id="77" creationId="{DE29D5F7-19BE-C513-B11F-D8D95DBF9D53}"/>
-          </ac:cxnSpMkLst>
-        </pc:cxnChg>
-        <pc:cxnChg chg="add del mod">
-          <ac:chgData name="Malte Hansen" userId="e2fbc9eb-1f72-4e56-aacd-c5bbbe39b840" providerId="ADAL" clId="{A2F0E014-A1BD-493F-914B-9F6C0B0FEA44}" dt="2026-05-05T11:15:45.872" v="325" actId="21"/>
-          <ac:cxnSpMkLst>
-            <pc:docMk/>
-            <pc:sldMk cId="1913651356" sldId="256"/>
-            <ac:cxnSpMk id="89" creationId="{0AFDAB69-BEBE-60D1-FEE1-49DDB8A021B3}"/>
+            <ac:cxnSpMk id="9" creationId="{CDC24E0F-D927-84A7-3BA9-ABFFEA545859}"/>
           </ac:cxnSpMkLst>
         </pc:cxnChg>
         <pc:cxnChg chg="add mod">
-          <ac:chgData name="Malte Hansen" userId="e2fbc9eb-1f72-4e56-aacd-c5bbbe39b840" providerId="ADAL" clId="{A2F0E014-A1BD-493F-914B-9F6C0B0FEA44}" dt="2026-05-05T11:16:47.578" v="332" actId="1076"/>
+          <ac:chgData name="Malte Hansen" userId="e2fbc9eb-1f72-4e56-aacd-c5bbbe39b840" providerId="ADAL" clId="{A2F0E014-A1BD-493F-914B-9F6C0B0FEA44}" dt="2026-05-14T11:22:54.879" v="615" actId="1076"/>
           <ac:cxnSpMkLst>
             <pc:docMk/>
             <pc:sldMk cId="1913651356" sldId="256"/>
@@ -566,19 +339,11 @@
           </ac:cxnSpMkLst>
         </pc:cxnChg>
         <pc:cxnChg chg="add mod">
-          <ac:chgData name="Malte Hansen" userId="e2fbc9eb-1f72-4e56-aacd-c5bbbe39b840" providerId="ADAL" clId="{A2F0E014-A1BD-493F-914B-9F6C0B0FEA44}" dt="2026-05-05T11:16:47.578" v="332" actId="1076"/>
+          <ac:chgData name="Malte Hansen" userId="e2fbc9eb-1f72-4e56-aacd-c5bbbe39b840" providerId="ADAL" clId="{A2F0E014-A1BD-493F-914B-9F6C0B0FEA44}" dt="2026-05-14T11:23:07.330" v="616" actId="1076"/>
           <ac:cxnSpMkLst>
             <pc:docMk/>
             <pc:sldMk cId="1913651356" sldId="256"/>
             <ac:cxnSpMk id="93" creationId="{116D635F-2556-2A47-9979-A6346FDDEBDB}"/>
-          </ac:cxnSpMkLst>
-        </pc:cxnChg>
-        <pc:cxnChg chg="add del mod">
-          <ac:chgData name="Malte Hansen" userId="e2fbc9eb-1f72-4e56-aacd-c5bbbe39b840" providerId="ADAL" clId="{A2F0E014-A1BD-493F-914B-9F6C0B0FEA44}" dt="2026-05-05T11:15:47.570" v="326" actId="21"/>
-          <ac:cxnSpMkLst>
-            <pc:docMk/>
-            <pc:sldMk cId="1913651356" sldId="256"/>
-            <ac:cxnSpMk id="95" creationId="{B485F37E-2C52-4870-6818-B90ADE6478B7}"/>
           </ac:cxnSpMkLst>
         </pc:cxnChg>
         <pc:cxnChg chg="add mod">
@@ -597,24 +362,8 @@
             <ac:cxnSpMk id="99" creationId="{59A45D60-C73F-77B9-350D-DF2241CF00C4}"/>
           </ac:cxnSpMkLst>
         </pc:cxnChg>
-        <pc:cxnChg chg="add del mod">
-          <ac:chgData name="Malte Hansen" userId="e2fbc9eb-1f72-4e56-aacd-c5bbbe39b840" providerId="ADAL" clId="{A2F0E014-A1BD-493F-914B-9F6C0B0FEA44}" dt="2026-05-05T11:47:23.017" v="548" actId="478"/>
-          <ac:cxnSpMkLst>
-            <pc:docMk/>
-            <pc:sldMk cId="1913651356" sldId="256"/>
-            <ac:cxnSpMk id="101" creationId="{D9FA88AE-5426-9DFE-FC1E-311BC99E511E}"/>
-          </ac:cxnSpMkLst>
-        </pc:cxnChg>
-        <pc:cxnChg chg="add del mod">
-          <ac:chgData name="Malte Hansen" userId="e2fbc9eb-1f72-4e56-aacd-c5bbbe39b840" providerId="ADAL" clId="{A2F0E014-A1BD-493F-914B-9F6C0B0FEA44}" dt="2026-05-05T11:47:01.313" v="545" actId="478"/>
-          <ac:cxnSpMkLst>
-            <pc:docMk/>
-            <pc:sldMk cId="1913651356" sldId="256"/>
-            <ac:cxnSpMk id="103" creationId="{6567A916-14B4-50BF-008D-D6E125B2F055}"/>
-          </ac:cxnSpMkLst>
-        </pc:cxnChg>
         <pc:cxnChg chg="add mod">
-          <ac:chgData name="Malte Hansen" userId="e2fbc9eb-1f72-4e56-aacd-c5bbbe39b840" providerId="ADAL" clId="{A2F0E014-A1BD-493F-914B-9F6C0B0FEA44}" dt="2026-05-05T11:25:50.314" v="414" actId="13822"/>
+          <ac:chgData name="Malte Hansen" userId="e2fbc9eb-1f72-4e56-aacd-c5bbbe39b840" providerId="ADAL" clId="{A2F0E014-A1BD-493F-914B-9F6C0B0FEA44}" dt="2026-05-14T11:21:54.279" v="607" actId="1076"/>
           <ac:cxnSpMkLst>
             <pc:docMk/>
             <pc:sldMk cId="1913651356" sldId="256"/>
@@ -622,7 +371,7 @@
           </ac:cxnSpMkLst>
         </pc:cxnChg>
         <pc:cxnChg chg="add mod">
-          <ac:chgData name="Malte Hansen" userId="e2fbc9eb-1f72-4e56-aacd-c5bbbe39b840" providerId="ADAL" clId="{A2F0E014-A1BD-493F-914B-9F6C0B0FEA44}" dt="2026-05-05T11:25:53.805" v="415" actId="13822"/>
+          <ac:chgData name="Malte Hansen" userId="e2fbc9eb-1f72-4e56-aacd-c5bbbe39b840" providerId="ADAL" clId="{A2F0E014-A1BD-493F-914B-9F6C0B0FEA44}" dt="2026-05-14T11:21:46.693" v="605" actId="1076"/>
           <ac:cxnSpMkLst>
             <pc:docMk/>
             <pc:sldMk cId="1913651356" sldId="256"/>
@@ -630,7 +379,7 @@
           </ac:cxnSpMkLst>
         </pc:cxnChg>
         <pc:cxnChg chg="add mod">
-          <ac:chgData name="Malte Hansen" userId="e2fbc9eb-1f72-4e56-aacd-c5bbbe39b840" providerId="ADAL" clId="{A2F0E014-A1BD-493F-914B-9F6C0B0FEA44}" dt="2026-05-05T11:25:35.267" v="410" actId="13822"/>
+          <ac:chgData name="Malte Hansen" userId="e2fbc9eb-1f72-4e56-aacd-c5bbbe39b840" providerId="ADAL" clId="{A2F0E014-A1BD-493F-914B-9F6C0B0FEA44}" dt="2026-05-14T11:22:54.879" v="615" actId="1076"/>
           <ac:cxnSpMkLst>
             <pc:docMk/>
             <pc:sldMk cId="1913651356" sldId="256"/>
@@ -638,7 +387,7 @@
           </ac:cxnSpMkLst>
         </pc:cxnChg>
         <pc:cxnChg chg="add mod">
-          <ac:chgData name="Malte Hansen" userId="e2fbc9eb-1f72-4e56-aacd-c5bbbe39b840" providerId="ADAL" clId="{A2F0E014-A1BD-493F-914B-9F6C0B0FEA44}" dt="2026-05-05T11:25:38.646" v="411" actId="13822"/>
+          <ac:chgData name="Malte Hansen" userId="e2fbc9eb-1f72-4e56-aacd-c5bbbe39b840" providerId="ADAL" clId="{A2F0E014-A1BD-493F-914B-9F6C0B0FEA44}" dt="2026-05-14T11:23:07.330" v="616" actId="1076"/>
           <ac:cxnSpMkLst>
             <pc:docMk/>
             <pc:sldMk cId="1913651356" sldId="256"/>
@@ -646,31 +395,15 @@
           </ac:cxnSpMkLst>
         </pc:cxnChg>
         <pc:cxnChg chg="add del mod">
-          <ac:chgData name="Malte Hansen" userId="e2fbc9eb-1f72-4e56-aacd-c5bbbe39b840" providerId="ADAL" clId="{A2F0E014-A1BD-493F-914B-9F6C0B0FEA44}" dt="2026-05-05T11:20:29.953" v="348" actId="21"/>
-          <ac:cxnSpMkLst>
-            <pc:docMk/>
-            <pc:sldMk cId="1913651356" sldId="256"/>
-            <ac:cxnSpMk id="131" creationId="{70B779DC-4687-4F56-CE02-1BB09E5DA51A}"/>
-          </ac:cxnSpMkLst>
-        </pc:cxnChg>
-        <pc:cxnChg chg="add mod">
-          <ac:chgData name="Malte Hansen" userId="e2fbc9eb-1f72-4e56-aacd-c5bbbe39b840" providerId="ADAL" clId="{A2F0E014-A1BD-493F-914B-9F6C0B0FEA44}" dt="2026-05-05T11:41:56.497" v="517" actId="1076"/>
+          <ac:chgData name="Malte Hansen" userId="e2fbc9eb-1f72-4e56-aacd-c5bbbe39b840" providerId="ADAL" clId="{A2F0E014-A1BD-493F-914B-9F6C0B0FEA44}" dt="2026-05-14T11:19:18.470" v="587" actId="478"/>
           <ac:cxnSpMkLst>
             <pc:docMk/>
             <pc:sldMk cId="1913651356" sldId="256"/>
             <ac:cxnSpMk id="137" creationId="{40D65F85-F15F-DA78-652A-D568732B2590}"/>
           </ac:cxnSpMkLst>
         </pc:cxnChg>
-        <pc:cxnChg chg="add del">
-          <ac:chgData name="Malte Hansen" userId="e2fbc9eb-1f72-4e56-aacd-c5bbbe39b840" providerId="ADAL" clId="{A2F0E014-A1BD-493F-914B-9F6C0B0FEA44}" dt="2026-05-05T11:30:58.177" v="423" actId="21"/>
-          <ac:cxnSpMkLst>
-            <pc:docMk/>
-            <pc:sldMk cId="1913651356" sldId="256"/>
-            <ac:cxnSpMk id="139" creationId="{8744C4F8-362C-78CF-5485-1A8A7B692C19}"/>
-          </ac:cxnSpMkLst>
-        </pc:cxnChg>
-        <pc:cxnChg chg="add mod">
-          <ac:chgData name="Malte Hansen" userId="e2fbc9eb-1f72-4e56-aacd-c5bbbe39b840" providerId="ADAL" clId="{A2F0E014-A1BD-493F-914B-9F6C0B0FEA44}" dt="2026-05-05T11:46:32.787" v="539" actId="164"/>
+        <pc:cxnChg chg="add del mod">
+          <ac:chgData name="Malte Hansen" userId="e2fbc9eb-1f72-4e56-aacd-c5bbbe39b840" providerId="ADAL" clId="{A2F0E014-A1BD-493F-914B-9F6C0B0FEA44}" dt="2026-05-14T11:19:20.992" v="588" actId="478"/>
           <ac:cxnSpMkLst>
             <pc:docMk/>
             <pc:sldMk cId="1913651356" sldId="256"/>
@@ -678,31 +411,15 @@
           </ac:cxnSpMkLst>
         </pc:cxnChg>
         <pc:cxnChg chg="add del mod">
-          <ac:chgData name="Malte Hansen" userId="e2fbc9eb-1f72-4e56-aacd-c5bbbe39b840" providerId="ADAL" clId="{A2F0E014-A1BD-493F-914B-9F6C0B0FEA44}" dt="2026-05-05T11:35:03.489" v="448" actId="21"/>
-          <ac:cxnSpMkLst>
-            <pc:docMk/>
-            <pc:sldMk cId="1913651356" sldId="256"/>
-            <ac:cxnSpMk id="146" creationId="{A33BBA5A-8E15-BAAB-C133-7FCDA543A94F}"/>
-          </ac:cxnSpMkLst>
-        </pc:cxnChg>
-        <pc:cxnChg chg="add del mod">
-          <ac:chgData name="Malte Hansen" userId="e2fbc9eb-1f72-4e56-aacd-c5bbbe39b840" providerId="ADAL" clId="{A2F0E014-A1BD-493F-914B-9F6C0B0FEA44}" dt="2026-05-05T11:35:02.035" v="447" actId="21"/>
-          <ac:cxnSpMkLst>
-            <pc:docMk/>
-            <pc:sldMk cId="1913651356" sldId="256"/>
-            <ac:cxnSpMk id="147" creationId="{DF340486-4F3E-4E5A-220F-F77419350B4A}"/>
-          </ac:cxnSpMkLst>
-        </pc:cxnChg>
-        <pc:cxnChg chg="add mod">
-          <ac:chgData name="Malte Hansen" userId="e2fbc9eb-1f72-4e56-aacd-c5bbbe39b840" providerId="ADAL" clId="{A2F0E014-A1BD-493F-914B-9F6C0B0FEA44}" dt="2026-05-05T11:46:32.787" v="539" actId="164"/>
+          <ac:chgData name="Malte Hansen" userId="e2fbc9eb-1f72-4e56-aacd-c5bbbe39b840" providerId="ADAL" clId="{A2F0E014-A1BD-493F-914B-9F6C0B0FEA44}" dt="2026-05-14T11:19:07.883" v="584" actId="478"/>
           <ac:cxnSpMkLst>
             <pc:docMk/>
             <pc:sldMk cId="1913651356" sldId="256"/>
             <ac:cxnSpMk id="151" creationId="{1EC051D2-1A9B-15C4-E2BB-B3B84FDEAF61}"/>
           </ac:cxnSpMkLst>
         </pc:cxnChg>
-        <pc:cxnChg chg="add mod">
-          <ac:chgData name="Malte Hansen" userId="e2fbc9eb-1f72-4e56-aacd-c5bbbe39b840" providerId="ADAL" clId="{A2F0E014-A1BD-493F-914B-9F6C0B0FEA44}" dt="2026-05-05T11:41:56.497" v="517" actId="1076"/>
+        <pc:cxnChg chg="add del mod">
+          <ac:chgData name="Malte Hansen" userId="e2fbc9eb-1f72-4e56-aacd-c5bbbe39b840" providerId="ADAL" clId="{A2F0E014-A1BD-493F-914B-9F6C0B0FEA44}" dt="2026-05-14T11:19:10.883" v="585" actId="478"/>
           <ac:cxnSpMkLst>
             <pc:docMk/>
             <pc:sldMk cId="1913651356" sldId="256"/>
@@ -710,15 +427,7 @@
           </ac:cxnSpMkLst>
         </pc:cxnChg>
         <pc:cxnChg chg="add del mod">
-          <ac:chgData name="Malte Hansen" userId="e2fbc9eb-1f72-4e56-aacd-c5bbbe39b840" providerId="ADAL" clId="{A2F0E014-A1BD-493F-914B-9F6C0B0FEA44}" dt="2026-05-05T11:49:21.145" v="568" actId="478"/>
-          <ac:cxnSpMkLst>
-            <pc:docMk/>
-            <pc:sldMk cId="1913651356" sldId="256"/>
-            <ac:cxnSpMk id="172" creationId="{D37AB82F-E690-9D6B-DBBE-6D575AAE9BCE}"/>
-          </ac:cxnSpMkLst>
-        </pc:cxnChg>
-        <pc:cxnChg chg="add mod">
-          <ac:chgData name="Malte Hansen" userId="e2fbc9eb-1f72-4e56-aacd-c5bbbe39b840" providerId="ADAL" clId="{A2F0E014-A1BD-493F-914B-9F6C0B0FEA44}" dt="2026-05-05T11:50:45.368" v="581" actId="13822"/>
+          <ac:chgData name="Malte Hansen" userId="e2fbc9eb-1f72-4e56-aacd-c5bbbe39b840" providerId="ADAL" clId="{A2F0E014-A1BD-493F-914B-9F6C0B0FEA44}" dt="2026-05-14T11:20:42.165" v="594" actId="478"/>
           <ac:cxnSpMkLst>
             <pc:docMk/>
             <pc:sldMk cId="1913651356" sldId="256"/>
@@ -726,31 +435,23 @@
           </ac:cxnSpMkLst>
         </pc:cxnChg>
         <pc:cxnChg chg="add del mod">
-          <ac:chgData name="Malte Hansen" userId="e2fbc9eb-1f72-4e56-aacd-c5bbbe39b840" providerId="ADAL" clId="{A2F0E014-A1BD-493F-914B-9F6C0B0FEA44}" dt="2026-05-05T11:49:28.498" v="570" actId="478"/>
-          <ac:cxnSpMkLst>
-            <pc:docMk/>
-            <pc:sldMk cId="1913651356" sldId="256"/>
-            <ac:cxnSpMk id="176" creationId="{D5B9E26A-CBC3-D8B5-72BB-78815C8ADBAE}"/>
-          </ac:cxnSpMkLst>
-        </pc:cxnChg>
-        <pc:cxnChg chg="add mod">
-          <ac:chgData name="Malte Hansen" userId="e2fbc9eb-1f72-4e56-aacd-c5bbbe39b840" providerId="ADAL" clId="{A2F0E014-A1BD-493F-914B-9F6C0B0FEA44}" dt="2026-05-05T11:50:45.368" v="581" actId="13822"/>
+          <ac:chgData name="Malte Hansen" userId="e2fbc9eb-1f72-4e56-aacd-c5bbbe39b840" providerId="ADAL" clId="{A2F0E014-A1BD-493F-914B-9F6C0B0FEA44}" dt="2026-05-14T11:21:20.565" v="599" actId="478"/>
           <ac:cxnSpMkLst>
             <pc:docMk/>
             <pc:sldMk cId="1913651356" sldId="256"/>
             <ac:cxnSpMk id="178" creationId="{E2AFF61A-6168-8EC2-797E-76804261AE05}"/>
           </ac:cxnSpMkLst>
         </pc:cxnChg>
-        <pc:cxnChg chg="add mod">
-          <ac:chgData name="Malte Hansen" userId="e2fbc9eb-1f72-4e56-aacd-c5bbbe39b840" providerId="ADAL" clId="{A2F0E014-A1BD-493F-914B-9F6C0B0FEA44}" dt="2026-05-05T11:50:45.368" v="581" actId="13822"/>
+        <pc:cxnChg chg="add del mod">
+          <ac:chgData name="Malte Hansen" userId="e2fbc9eb-1f72-4e56-aacd-c5bbbe39b840" providerId="ADAL" clId="{A2F0E014-A1BD-493F-914B-9F6C0B0FEA44}" dt="2026-05-14T11:21:57.343" v="608" actId="478"/>
           <ac:cxnSpMkLst>
             <pc:docMk/>
             <pc:sldMk cId="1913651356" sldId="256"/>
             <ac:cxnSpMk id="187" creationId="{8B84FD31-98BE-6E29-07F3-6F78702A468F}"/>
           </ac:cxnSpMkLst>
         </pc:cxnChg>
-        <pc:cxnChg chg="add mod">
-          <ac:chgData name="Malte Hansen" userId="e2fbc9eb-1f72-4e56-aacd-c5bbbe39b840" providerId="ADAL" clId="{A2F0E014-A1BD-493F-914B-9F6C0B0FEA44}" dt="2026-05-05T11:50:45.368" v="581" actId="13822"/>
+        <pc:cxnChg chg="add del mod">
+          <ac:chgData name="Malte Hansen" userId="e2fbc9eb-1f72-4e56-aacd-c5bbbe39b840" providerId="ADAL" clId="{A2F0E014-A1BD-493F-914B-9F6C0B0FEA44}" dt="2026-05-14T11:21:33.979" v="602" actId="478"/>
           <ac:cxnSpMkLst>
             <pc:docMk/>
             <pc:sldMk cId="1913651356" sldId="256"/>
@@ -845,7 +546,7 @@
           <a:p>
             <a:fld id="{0E787CFE-0BD1-49B8-81EA-EE46B429A588}" type="datetimeFigureOut">
               <a:rPr lang="en-DK" smtClean="0"/>
-              <a:t>05/05/2026</a:t>
+              <a:t>14/05/2026</a:t>
             </a:fld>
             <a:endParaRPr lang="en-DK"/>
           </a:p>
@@ -1346,7 +1047,7 @@
           <a:p>
             <a:fld id="{CC906CCD-8861-419E-A404-81090EBDE48E}" type="datetimeFigureOut">
               <a:rPr lang="en-DK" smtClean="0"/>
-              <a:t>05/05/2026</a:t>
+              <a:t>14/05/2026</a:t>
             </a:fld>
             <a:endParaRPr lang="en-DK"/>
           </a:p>
@@ -1546,7 +1247,7 @@
           <a:p>
             <a:fld id="{CC906CCD-8861-419E-A404-81090EBDE48E}" type="datetimeFigureOut">
               <a:rPr lang="en-DK" smtClean="0"/>
-              <a:t>05/05/2026</a:t>
+              <a:t>14/05/2026</a:t>
             </a:fld>
             <a:endParaRPr lang="en-DK"/>
           </a:p>
@@ -1756,7 +1457,7 @@
           <a:p>
             <a:fld id="{CC906CCD-8861-419E-A404-81090EBDE48E}" type="datetimeFigureOut">
               <a:rPr lang="en-DK" smtClean="0"/>
-              <a:t>05/05/2026</a:t>
+              <a:t>14/05/2026</a:t>
             </a:fld>
             <a:endParaRPr lang="en-DK"/>
           </a:p>
@@ -1956,7 +1657,7 @@
           <a:p>
             <a:fld id="{CC906CCD-8861-419E-A404-81090EBDE48E}" type="datetimeFigureOut">
               <a:rPr lang="en-DK" smtClean="0"/>
-              <a:t>05/05/2026</a:t>
+              <a:t>14/05/2026</a:t>
             </a:fld>
             <a:endParaRPr lang="en-DK"/>
           </a:p>
@@ -2232,7 +1933,7 @@
           <a:p>
             <a:fld id="{CC906CCD-8861-419E-A404-81090EBDE48E}" type="datetimeFigureOut">
               <a:rPr lang="en-DK" smtClean="0"/>
-              <a:t>05/05/2026</a:t>
+              <a:t>14/05/2026</a:t>
             </a:fld>
             <a:endParaRPr lang="en-DK"/>
           </a:p>
@@ -2500,7 +2201,7 @@
           <a:p>
             <a:fld id="{CC906CCD-8861-419E-A404-81090EBDE48E}" type="datetimeFigureOut">
               <a:rPr lang="en-DK" smtClean="0"/>
-              <a:t>05/05/2026</a:t>
+              <a:t>14/05/2026</a:t>
             </a:fld>
             <a:endParaRPr lang="en-DK"/>
           </a:p>
@@ -2915,7 +2616,7 @@
           <a:p>
             <a:fld id="{CC906CCD-8861-419E-A404-81090EBDE48E}" type="datetimeFigureOut">
               <a:rPr lang="en-DK" smtClean="0"/>
-              <a:t>05/05/2026</a:t>
+              <a:t>14/05/2026</a:t>
             </a:fld>
             <a:endParaRPr lang="en-DK"/>
           </a:p>
@@ -3057,7 +2758,7 @@
           <a:p>
             <a:fld id="{CC906CCD-8861-419E-A404-81090EBDE48E}" type="datetimeFigureOut">
               <a:rPr lang="en-DK" smtClean="0"/>
-              <a:t>05/05/2026</a:t>
+              <a:t>14/05/2026</a:t>
             </a:fld>
             <a:endParaRPr lang="en-DK"/>
           </a:p>
@@ -3170,7 +2871,7 @@
           <a:p>
             <a:fld id="{CC906CCD-8861-419E-A404-81090EBDE48E}" type="datetimeFigureOut">
               <a:rPr lang="en-DK" smtClean="0"/>
-              <a:t>05/05/2026</a:t>
+              <a:t>14/05/2026</a:t>
             </a:fld>
             <a:endParaRPr lang="en-DK"/>
           </a:p>
@@ -3483,7 +3184,7 @@
           <a:p>
             <a:fld id="{CC906CCD-8861-419E-A404-81090EBDE48E}" type="datetimeFigureOut">
               <a:rPr lang="en-DK" smtClean="0"/>
-              <a:t>05/05/2026</a:t>
+              <a:t>14/05/2026</a:t>
             </a:fld>
             <a:endParaRPr lang="en-DK"/>
           </a:p>
@@ -3772,7 +3473,7 @@
           <a:p>
             <a:fld id="{CC906CCD-8861-419E-A404-81090EBDE48E}" type="datetimeFigureOut">
               <a:rPr lang="en-DK" smtClean="0"/>
-              <a:t>05/05/2026</a:t>
+              <a:t>14/05/2026</a:t>
             </a:fld>
             <a:endParaRPr lang="en-DK"/>
           </a:p>
@@ -4015,7 +3716,7 @@
           <a:p>
             <a:fld id="{CC906CCD-8861-419E-A404-81090EBDE48E}" type="datetimeFigureOut">
               <a:rPr lang="en-DK" smtClean="0"/>
-              <a:t>05/05/2026</a:t>
+              <a:t>14/05/2026</a:t>
             </a:fld>
             <a:endParaRPr lang="en-DK"/>
           </a:p>
@@ -4434,10 +4135,10 @@
       </p:grpSpPr>
       <p:grpSp>
         <p:nvGrpSpPr>
-          <p:cNvPr id="190" name="Group 189">
-            <a:extLst>
-              <a:ext uri="{FF2B5EF4-FFF2-40B4-BE49-F238E27FC236}">
-                <a16:creationId xmlns:a16="http://schemas.microsoft.com/office/drawing/2014/main" id="{2F4DFEBD-3EA2-B74A-11D9-391147CC5163}"/>
+          <p:cNvPr id="12" name="Group 11">
+            <a:extLst>
+              <a:ext uri="{FF2B5EF4-FFF2-40B4-BE49-F238E27FC236}">
+                <a16:creationId xmlns:a16="http://schemas.microsoft.com/office/drawing/2014/main" id="{9D117CD8-85D8-B923-09BA-94C97C1B3774}"/>
               </a:ext>
             </a:extLst>
           </p:cNvPr>
@@ -4446,1722 +4147,632 @@
         </p:nvGrpSpPr>
         <p:grpSpPr>
           <a:xfrm>
-            <a:off x="261771" y="2116384"/>
-            <a:ext cx="11576508" cy="2625232"/>
-            <a:chOff x="261771" y="2116384"/>
-            <a:chExt cx="11576508" cy="2625232"/>
+            <a:off x="1281477" y="2110909"/>
+            <a:ext cx="9629046" cy="2636179"/>
+            <a:chOff x="1281477" y="2110909"/>
+            <a:chExt cx="9629046" cy="2636179"/>
           </a:xfrm>
         </p:grpSpPr>
-        <p:grpSp>
-          <p:nvGrpSpPr>
-            <p:cNvPr id="168" name="Group 167">
+        <p:sp>
+          <p:nvSpPr>
+            <p:cNvPr id="134" name="Rectangle: Rounded Corners 133">
               <a:extLst>
                 <a:ext uri="{FF2B5EF4-FFF2-40B4-BE49-F238E27FC236}">
-                  <a16:creationId xmlns:a16="http://schemas.microsoft.com/office/drawing/2014/main" id="{A7C52BBE-F462-0C7D-41CC-54BFEC41BD2A}"/>
+                  <a16:creationId xmlns:a16="http://schemas.microsoft.com/office/drawing/2014/main" id="{D0F8105A-A570-D521-28A7-7D375D73F45C}"/>
                 </a:ext>
               </a:extLst>
             </p:cNvPr>
-            <p:cNvGrpSpPr/>
+            <p:cNvSpPr/>
             <p:nvPr/>
-          </p:nvGrpSpPr>
-          <p:grpSpPr>
+          </p:nvSpPr>
+          <p:spPr>
             <a:xfrm>
-              <a:off x="261771" y="2116384"/>
-              <a:ext cx="11576508" cy="2625232"/>
-              <a:chOff x="261771" y="2116384"/>
-              <a:chExt cx="11576508" cy="2625232"/>
+              <a:off x="4588731" y="2662122"/>
+              <a:ext cx="3018701" cy="1625382"/>
             </a:xfrm>
-          </p:grpSpPr>
-          <p:grpSp>
-            <p:nvGrpSpPr>
-              <p:cNvPr id="135" name="Group 134">
-                <a:extLst>
-                  <a:ext uri="{FF2B5EF4-FFF2-40B4-BE49-F238E27FC236}">
-                    <a16:creationId xmlns:a16="http://schemas.microsoft.com/office/drawing/2014/main" id="{E4882EA7-5F48-A317-041F-C5F8798A6B09}"/>
-                  </a:ext>
-                </a:extLst>
-              </p:cNvPr>
-              <p:cNvGrpSpPr/>
-              <p:nvPr/>
-            </p:nvGrpSpPr>
-            <p:grpSpPr>
-              <a:xfrm>
-                <a:off x="1281477" y="2116384"/>
-                <a:ext cx="9629046" cy="2625232"/>
-                <a:chOff x="61294" y="2173343"/>
-                <a:chExt cx="11944075" cy="3045564"/>
-              </a:xfrm>
-            </p:grpSpPr>
-            <p:sp>
-              <p:nvSpPr>
-                <p:cNvPr id="134" name="Rectangle: Rounded Corners 133">
-                  <a:extLst>
-                    <a:ext uri="{FF2B5EF4-FFF2-40B4-BE49-F238E27FC236}">
-                      <a16:creationId xmlns:a16="http://schemas.microsoft.com/office/drawing/2014/main" id="{D0F8105A-A570-D521-28A7-7D375D73F45C}"/>
-                    </a:ext>
-                  </a:extLst>
-                </p:cNvPr>
-                <p:cNvSpPr/>
-                <p:nvPr/>
-              </p:nvSpPr>
-              <p:spPr>
-                <a:xfrm>
-                  <a:off x="4163683" y="2806460"/>
-                  <a:ext cx="3744461" cy="1885626"/>
-                </a:xfrm>
-                <a:prstGeom prst="roundRect">
-                  <a:avLst/>
-                </a:prstGeom>
-              </p:spPr>
-              <p:style>
-                <a:lnRef idx="1">
-                  <a:schemeClr val="dk1"/>
-                </a:lnRef>
-                <a:fillRef idx="2">
-                  <a:schemeClr val="dk1"/>
-                </a:fillRef>
-                <a:effectRef idx="1">
-                  <a:schemeClr val="dk1"/>
-                </a:effectRef>
-                <a:fontRef idx="minor">
-                  <a:schemeClr val="dk1"/>
-                </a:fontRef>
-              </p:style>
-              <p:txBody>
-                <a:bodyPr rtlCol="0" anchor="ctr"/>
-                <a:lstStyle/>
-                <a:p>
-                  <a:pPr algn="ctr"/>
-                  <a:endParaRPr lang="en-DK"/>
-                </a:p>
-              </p:txBody>
-            </p:sp>
-            <p:sp>
-              <p:nvSpPr>
-                <p:cNvPr id="4" name="Rectangle: Rounded Corners 3">
-                  <a:extLst>
-                    <a:ext uri="{FF2B5EF4-FFF2-40B4-BE49-F238E27FC236}">
-                      <a16:creationId xmlns:a16="http://schemas.microsoft.com/office/drawing/2014/main" id="{6814767B-0783-F40C-C088-0D3F8E6482AE}"/>
-                    </a:ext>
-                  </a:extLst>
-                </p:cNvPr>
-                <p:cNvSpPr/>
-                <p:nvPr/>
-              </p:nvSpPr>
-              <p:spPr>
-                <a:xfrm>
-                  <a:off x="4332317" y="3309498"/>
-                  <a:ext cx="1461711" cy="878738"/>
-                </a:xfrm>
-                <a:prstGeom prst="roundRect">
-                  <a:avLst/>
-                </a:prstGeom>
-              </p:spPr>
-              <p:style>
-                <a:lnRef idx="1">
-                  <a:schemeClr val="accent4"/>
-                </a:lnRef>
-                <a:fillRef idx="2">
-                  <a:schemeClr val="accent4"/>
-                </a:fillRef>
-                <a:effectRef idx="1">
-                  <a:schemeClr val="accent4"/>
-                </a:effectRef>
-                <a:fontRef idx="minor">
-                  <a:schemeClr val="dk1"/>
-                </a:fontRef>
-              </p:style>
-              <p:txBody>
-                <a:bodyPr rtlCol="0" anchor="ctr"/>
-                <a:lstStyle/>
-                <a:p>
-                  <a:pPr algn="ctr"/>
-                  <a:r>
-                    <a:rPr lang="en-GB" sz="1400" dirty="0"/>
-                    <a:t>Core,  Heavy Water</a:t>
-                  </a:r>
-                  <a:endParaRPr lang="en-DK" sz="1400" dirty="0"/>
-                </a:p>
-              </p:txBody>
-            </p:sp>
-            <p:sp>
-              <p:nvSpPr>
-                <p:cNvPr id="5" name="Rectangle: Rounded Corners 4">
-                  <a:extLst>
-                    <a:ext uri="{FF2B5EF4-FFF2-40B4-BE49-F238E27FC236}">
-                      <a16:creationId xmlns:a16="http://schemas.microsoft.com/office/drawing/2014/main" id="{F0D813E4-EC22-E518-18EB-5E5DE4C554F8}"/>
-                    </a:ext>
-                  </a:extLst>
-                </p:cNvPr>
-                <p:cNvSpPr/>
-                <p:nvPr/>
-              </p:nvSpPr>
-              <p:spPr>
-                <a:xfrm>
-                  <a:off x="8491871" y="3303147"/>
-                  <a:ext cx="1461711" cy="878738"/>
-                </a:xfrm>
-                <a:prstGeom prst="roundRect">
-                  <a:avLst/>
-                </a:prstGeom>
-              </p:spPr>
-              <p:style>
-                <a:lnRef idx="1">
-                  <a:schemeClr val="accent2"/>
-                </a:lnRef>
-                <a:fillRef idx="2">
-                  <a:schemeClr val="accent2"/>
-                </a:fillRef>
-                <a:effectRef idx="1">
-                  <a:schemeClr val="accent2"/>
-                </a:effectRef>
-                <a:fontRef idx="minor">
-                  <a:schemeClr val="dk1"/>
-                </a:fontRef>
-              </p:style>
-              <p:txBody>
-                <a:bodyPr rtlCol="0" anchor="ctr"/>
-                <a:lstStyle/>
-                <a:p>
-                  <a:pPr algn="ctr"/>
-                  <a:r>
-                    <a:rPr lang="en-GB" sz="1400" dirty="0"/>
-                    <a:t>Heat Exchanger</a:t>
-                  </a:r>
-                  <a:endParaRPr lang="en-DK" sz="1400" dirty="0"/>
-                </a:p>
-              </p:txBody>
-            </p:sp>
-            <p:sp>
-              <p:nvSpPr>
-                <p:cNvPr id="6" name="Isosceles Triangle 5">
-                  <a:extLst>
-                    <a:ext uri="{FF2B5EF4-FFF2-40B4-BE49-F238E27FC236}">
-                      <a16:creationId xmlns:a16="http://schemas.microsoft.com/office/drawing/2014/main" id="{A2BCEB2F-12D8-D5B4-1834-87486F885E98}"/>
-                    </a:ext>
-                  </a:extLst>
-                </p:cNvPr>
-                <p:cNvSpPr/>
-                <p:nvPr/>
-              </p:nvSpPr>
-              <p:spPr>
-                <a:xfrm rot="5400000">
-                  <a:off x="7864393" y="2210744"/>
-                  <a:ext cx="584006" cy="509203"/>
-                </a:xfrm>
-                <a:prstGeom prst="triangle">
-                  <a:avLst/>
-                </a:prstGeom>
-              </p:spPr>
-              <p:style>
-                <a:lnRef idx="2">
-                  <a:schemeClr val="dk1"/>
-                </a:lnRef>
-                <a:fillRef idx="1">
-                  <a:schemeClr val="lt1"/>
-                </a:fillRef>
-                <a:effectRef idx="0">
-                  <a:schemeClr val="dk1"/>
-                </a:effectRef>
-                <a:fontRef idx="minor">
-                  <a:schemeClr val="dk1"/>
-                </a:fontRef>
-              </p:style>
-              <p:txBody>
-                <a:bodyPr rtlCol="0" anchor="ctr"/>
-                <a:lstStyle/>
-                <a:p>
-                  <a:pPr algn="ctr"/>
-                  <a:endParaRPr lang="en-DK" dirty="0"/>
-                </a:p>
-              </p:txBody>
-            </p:sp>
-            <p:sp>
-              <p:nvSpPr>
-                <p:cNvPr id="7" name="Isosceles Triangle 6">
-                  <a:extLst>
-                    <a:ext uri="{FF2B5EF4-FFF2-40B4-BE49-F238E27FC236}">
-                      <a16:creationId xmlns:a16="http://schemas.microsoft.com/office/drawing/2014/main" id="{C5D8EAD3-B018-605A-1B0C-E2218D1A91B2}"/>
-                    </a:ext>
-                  </a:extLst>
-                </p:cNvPr>
-                <p:cNvSpPr/>
-                <p:nvPr/>
-              </p:nvSpPr>
-              <p:spPr>
-                <a:xfrm rot="16200000">
-                  <a:off x="7864392" y="4672302"/>
-                  <a:ext cx="584006" cy="509203"/>
-                </a:xfrm>
-                <a:prstGeom prst="triangle">
-                  <a:avLst/>
-                </a:prstGeom>
-              </p:spPr>
-              <p:style>
-                <a:lnRef idx="2">
-                  <a:schemeClr val="dk1"/>
-                </a:lnRef>
-                <a:fillRef idx="1">
-                  <a:schemeClr val="lt1"/>
-                </a:fillRef>
-                <a:effectRef idx="0">
-                  <a:schemeClr val="dk1"/>
-                </a:effectRef>
-                <a:fontRef idx="minor">
-                  <a:schemeClr val="dk1"/>
-                </a:fontRef>
-              </p:style>
-              <p:txBody>
-                <a:bodyPr rtlCol="0" anchor="ctr"/>
-                <a:lstStyle/>
-                <a:p>
-                  <a:pPr algn="ctr"/>
-                  <a:endParaRPr lang="en-DK"/>
-                </a:p>
-              </p:txBody>
-            </p:sp>
-            <p:sp>
-              <p:nvSpPr>
-                <p:cNvPr id="24" name="Rectangle: Rounded Corners 23">
-                  <a:extLst>
-                    <a:ext uri="{FF2B5EF4-FFF2-40B4-BE49-F238E27FC236}">
-                      <a16:creationId xmlns:a16="http://schemas.microsoft.com/office/drawing/2014/main" id="{B9CC57FA-F63C-464C-AC90-408AD39B565A}"/>
-                    </a:ext>
-                  </a:extLst>
-                </p:cNvPr>
-                <p:cNvSpPr/>
-                <p:nvPr/>
-              </p:nvSpPr>
-              <p:spPr>
-                <a:xfrm>
-                  <a:off x="10543658" y="3303147"/>
-                  <a:ext cx="1461711" cy="878738"/>
-                </a:xfrm>
-                <a:prstGeom prst="roundRect">
-                  <a:avLst/>
-                </a:prstGeom>
-                <a:effectLst/>
-              </p:spPr>
-              <p:style>
-                <a:lnRef idx="1">
-                  <a:schemeClr val="accent2"/>
-                </a:lnRef>
-                <a:fillRef idx="2">
-                  <a:schemeClr val="accent2"/>
-                </a:fillRef>
-                <a:effectRef idx="1">
-                  <a:schemeClr val="accent2"/>
-                </a:effectRef>
-                <a:fontRef idx="minor">
-                  <a:schemeClr val="dk1"/>
-                </a:fontRef>
-              </p:style>
-              <p:txBody>
-                <a:bodyPr rtlCol="0" anchor="ctr"/>
-                <a:lstStyle/>
-                <a:p>
-                  <a:pPr algn="ctr"/>
-                  <a:r>
-                    <a:rPr lang="en-GB" sz="1400" dirty="0"/>
-                    <a:t>Helium Coolant</a:t>
-                  </a:r>
-                  <a:endParaRPr lang="en-DK" sz="1400" dirty="0"/>
-                </a:p>
-              </p:txBody>
-            </p:sp>
-            <p:sp>
-              <p:nvSpPr>
-                <p:cNvPr id="25" name="Rectangle: Rounded Corners 24">
-                  <a:extLst>
-                    <a:ext uri="{FF2B5EF4-FFF2-40B4-BE49-F238E27FC236}">
-                      <a16:creationId xmlns:a16="http://schemas.microsoft.com/office/drawing/2014/main" id="{4D832E5E-136E-5381-B4A6-510DCE1FEF0C}"/>
-                    </a:ext>
-                  </a:extLst>
-                </p:cNvPr>
-                <p:cNvSpPr/>
-                <p:nvPr/>
-              </p:nvSpPr>
-              <p:spPr>
-                <a:xfrm>
-                  <a:off x="2113082" y="3282678"/>
-                  <a:ext cx="1461711" cy="878738"/>
-                </a:xfrm>
-                <a:prstGeom prst="roundRect">
-                  <a:avLst/>
-                </a:prstGeom>
-              </p:spPr>
-              <p:style>
-                <a:lnRef idx="1">
-                  <a:schemeClr val="accent4"/>
-                </a:lnRef>
-                <a:fillRef idx="2">
-                  <a:schemeClr val="accent4"/>
-                </a:fillRef>
-                <a:effectRef idx="1">
-                  <a:schemeClr val="accent4"/>
-                </a:effectRef>
-                <a:fontRef idx="minor">
-                  <a:schemeClr val="dk1"/>
-                </a:fontRef>
-              </p:style>
-              <p:txBody>
-                <a:bodyPr rtlCol="0" anchor="ctr"/>
-                <a:lstStyle/>
-                <a:p>
-                  <a:pPr algn="ctr"/>
-                  <a:r>
-                    <a:rPr lang="en-GB" sz="1400" dirty="0"/>
-                    <a:t>Heat Exchanger</a:t>
-                  </a:r>
-                  <a:endParaRPr lang="en-DK" sz="1400" dirty="0"/>
-                </a:p>
-              </p:txBody>
-            </p:sp>
-            <p:sp>
-              <p:nvSpPr>
-                <p:cNvPr id="54" name="Rectangle: Rounded Corners 53">
-                  <a:extLst>
-                    <a:ext uri="{FF2B5EF4-FFF2-40B4-BE49-F238E27FC236}">
-                      <a16:creationId xmlns:a16="http://schemas.microsoft.com/office/drawing/2014/main" id="{DFFE57D5-58A5-4A89-EFB5-F0F4C179224D}"/>
-                    </a:ext>
-                  </a:extLst>
-                </p:cNvPr>
-                <p:cNvSpPr/>
-                <p:nvPr/>
-              </p:nvSpPr>
-              <p:spPr>
-                <a:xfrm>
-                  <a:off x="61294" y="3303147"/>
-                  <a:ext cx="1461711" cy="878738"/>
-                </a:xfrm>
-                <a:prstGeom prst="roundRect">
-                  <a:avLst/>
-                </a:prstGeom>
-              </p:spPr>
-              <p:style>
-                <a:lnRef idx="1">
-                  <a:schemeClr val="accent4"/>
-                </a:lnRef>
-                <a:fillRef idx="2">
-                  <a:schemeClr val="accent4"/>
-                </a:fillRef>
-                <a:effectRef idx="1">
-                  <a:schemeClr val="accent4"/>
-                </a:effectRef>
-                <a:fontRef idx="minor">
-                  <a:schemeClr val="dk1"/>
-                </a:fontRef>
-              </p:style>
-              <p:txBody>
-                <a:bodyPr rtlCol="0" anchor="ctr"/>
-                <a:lstStyle/>
-                <a:p>
-                  <a:pPr algn="ctr"/>
-                  <a:r>
-                    <a:rPr lang="en-GB" sz="1400" dirty="0">
-                      <a:cs typeface="Aldhabi" panose="01000000000000000000" pitchFamily="2" charset="-78"/>
-                    </a:rPr>
-                    <a:t>Light Water Coolant</a:t>
-                  </a:r>
-                  <a:endParaRPr lang="en-DK" sz="1400" dirty="0">
-                    <a:cs typeface="Aldhabi" panose="01000000000000000000" pitchFamily="2" charset="-78"/>
-                  </a:endParaRPr>
-                </a:p>
-              </p:txBody>
-            </p:sp>
-            <p:sp>
-              <p:nvSpPr>
-                <p:cNvPr id="111" name="Rectangle: Rounded Corners 110">
-                  <a:extLst>
-                    <a:ext uri="{FF2B5EF4-FFF2-40B4-BE49-F238E27FC236}">
-                      <a16:creationId xmlns:a16="http://schemas.microsoft.com/office/drawing/2014/main" id="{2D86E45E-E479-1CC8-4526-F561E796C416}"/>
-                    </a:ext>
-                  </a:extLst>
-                </p:cNvPr>
-                <p:cNvSpPr/>
-                <p:nvPr/>
-              </p:nvSpPr>
-              <p:spPr>
-                <a:xfrm>
-                  <a:off x="6272636" y="3303146"/>
-                  <a:ext cx="1461711" cy="878738"/>
-                </a:xfrm>
-                <a:prstGeom prst="roundRect">
-                  <a:avLst/>
-                </a:prstGeom>
-              </p:spPr>
-              <p:style>
-                <a:lnRef idx="1">
-                  <a:schemeClr val="accent2"/>
-                </a:lnRef>
-                <a:fillRef idx="2">
-                  <a:schemeClr val="accent2"/>
-                </a:fillRef>
-                <a:effectRef idx="1">
-                  <a:schemeClr val="accent2"/>
-                </a:effectRef>
-                <a:fontRef idx="minor">
-                  <a:schemeClr val="dk1"/>
-                </a:fontRef>
-              </p:style>
-              <p:txBody>
-                <a:bodyPr rtlCol="0" anchor="ctr"/>
-                <a:lstStyle/>
-                <a:p>
-                  <a:pPr algn="ctr"/>
-                  <a:r>
-                    <a:rPr lang="en-GB" sz="1400" dirty="0"/>
-                    <a:t>Core, Fuel</a:t>
-                  </a:r>
-                  <a:endParaRPr lang="en-DK" sz="1400" dirty="0"/>
-                </a:p>
-              </p:txBody>
-            </p:sp>
-            <p:cxnSp>
-              <p:nvCxnSpPr>
-                <p:cNvPr id="91" name="Connector: Curved 90">
-                  <a:extLst>
-                    <a:ext uri="{FF2B5EF4-FFF2-40B4-BE49-F238E27FC236}">
-                      <a16:creationId xmlns:a16="http://schemas.microsoft.com/office/drawing/2014/main" id="{E48BAD00-07BD-7CEF-CDC4-E4096CB492A6}"/>
-                    </a:ext>
-                  </a:extLst>
-                </p:cNvPr>
-                <p:cNvCxnSpPr>
-                  <a:stCxn id="6" idx="0"/>
-                  <a:endCxn id="5" idx="0"/>
-                </p:cNvCxnSpPr>
-                <p:nvPr/>
-              </p:nvCxnSpPr>
-              <p:spPr>
-                <a:xfrm>
-                  <a:off x="8410998" y="2465346"/>
-                  <a:ext cx="811729" cy="837801"/>
-                </a:xfrm>
-                <a:prstGeom prst="curvedConnector2">
-                  <a:avLst/>
-                </a:prstGeom>
-                <a:ln>
-                  <a:tailEnd type="triangle"/>
-                </a:ln>
-              </p:spPr>
-              <p:style>
-                <a:lnRef idx="3">
-                  <a:schemeClr val="accent2"/>
-                </a:lnRef>
-                <a:fillRef idx="0">
-                  <a:schemeClr val="accent2"/>
-                </a:fillRef>
-                <a:effectRef idx="2">
-                  <a:schemeClr val="accent2"/>
-                </a:effectRef>
-                <a:fontRef idx="minor">
-                  <a:schemeClr val="tx1"/>
-                </a:fontRef>
-              </p:style>
-            </p:cxnSp>
-            <p:cxnSp>
-              <p:nvCxnSpPr>
-                <p:cNvPr id="93" name="Connector: Curved 92">
-                  <a:extLst>
-                    <a:ext uri="{FF2B5EF4-FFF2-40B4-BE49-F238E27FC236}">
-                      <a16:creationId xmlns:a16="http://schemas.microsoft.com/office/drawing/2014/main" id="{116D635F-2556-2A47-9979-A6346FDDEBDB}"/>
-                    </a:ext>
-                  </a:extLst>
-                </p:cNvPr>
-                <p:cNvCxnSpPr>
-                  <a:stCxn id="5" idx="2"/>
-                  <a:endCxn id="7" idx="3"/>
-                </p:cNvCxnSpPr>
-                <p:nvPr/>
-              </p:nvCxnSpPr>
-              <p:spPr>
-                <a:xfrm rot="5400000">
-                  <a:off x="8444353" y="4148529"/>
-                  <a:ext cx="745019" cy="811730"/>
-                </a:xfrm>
-                <a:prstGeom prst="curvedConnector2">
-                  <a:avLst/>
-                </a:prstGeom>
-                <a:ln>
-                  <a:tailEnd type="triangle"/>
-                </a:ln>
-              </p:spPr>
-              <p:style>
-                <a:lnRef idx="3">
-                  <a:schemeClr val="accent2"/>
-                </a:lnRef>
-                <a:fillRef idx="0">
-                  <a:schemeClr val="accent2"/>
-                </a:fillRef>
-                <a:effectRef idx="2">
-                  <a:schemeClr val="accent2"/>
-                </a:effectRef>
-                <a:fontRef idx="minor">
-                  <a:schemeClr val="tx1"/>
-                </a:fontRef>
-              </p:style>
-            </p:cxnSp>
-            <p:cxnSp>
-              <p:nvCxnSpPr>
-                <p:cNvPr id="97" name="Connector: Curved 96">
-                  <a:extLst>
-                    <a:ext uri="{FF2B5EF4-FFF2-40B4-BE49-F238E27FC236}">
-                      <a16:creationId xmlns:a16="http://schemas.microsoft.com/office/drawing/2014/main" id="{6F7C95D4-84FA-3A61-189E-F624859D4D19}"/>
-                    </a:ext>
-                  </a:extLst>
-                </p:cNvPr>
-                <p:cNvCxnSpPr>
-                  <a:stCxn id="5" idx="0"/>
-                  <a:endCxn id="24" idx="0"/>
-                </p:cNvCxnSpPr>
-                <p:nvPr/>
-              </p:nvCxnSpPr>
-              <p:spPr>
-                <a:xfrm rot="5400000" flipH="1" flipV="1">
-                  <a:off x="10248620" y="2277254"/>
-                  <a:ext cx="12700" cy="2051787"/>
-                </a:xfrm>
-                <a:prstGeom prst="curvedConnector3">
-                  <a:avLst>
-                    <a:gd name="adj1" fmla="val 1800000"/>
-                  </a:avLst>
-                </a:prstGeom>
-                <a:ln>
-                  <a:tailEnd type="triangle"/>
-                </a:ln>
-              </p:spPr>
-              <p:style>
-                <a:lnRef idx="3">
-                  <a:schemeClr val="accent2"/>
-                </a:lnRef>
-                <a:fillRef idx="0">
-                  <a:schemeClr val="accent2"/>
-                </a:fillRef>
-                <a:effectRef idx="2">
-                  <a:schemeClr val="accent2"/>
-                </a:effectRef>
-                <a:fontRef idx="minor">
-                  <a:schemeClr val="tx1"/>
-                </a:fontRef>
-              </p:style>
-            </p:cxnSp>
-            <p:cxnSp>
-              <p:nvCxnSpPr>
-                <p:cNvPr id="99" name="Connector: Curved 98">
-                  <a:extLst>
-                    <a:ext uri="{FF2B5EF4-FFF2-40B4-BE49-F238E27FC236}">
-                      <a16:creationId xmlns:a16="http://schemas.microsoft.com/office/drawing/2014/main" id="{59A45D60-C73F-77B9-350D-DF2241CF00C4}"/>
-                    </a:ext>
-                  </a:extLst>
-                </p:cNvPr>
-                <p:cNvCxnSpPr>
-                  <a:stCxn id="24" idx="2"/>
-                  <a:endCxn id="5" idx="2"/>
-                </p:cNvCxnSpPr>
-                <p:nvPr/>
-              </p:nvCxnSpPr>
-              <p:spPr>
-                <a:xfrm rot="5400000">
-                  <a:off x="10248621" y="3155992"/>
-                  <a:ext cx="12700" cy="2051787"/>
-                </a:xfrm>
-                <a:prstGeom prst="curvedConnector3">
-                  <a:avLst>
-                    <a:gd name="adj1" fmla="val 1800000"/>
-                  </a:avLst>
-                </a:prstGeom>
-                <a:ln>
-                  <a:tailEnd type="triangle"/>
-                </a:ln>
-              </p:spPr>
-              <p:style>
-                <a:lnRef idx="3">
-                  <a:schemeClr val="accent2"/>
-                </a:lnRef>
-                <a:fillRef idx="0">
-                  <a:schemeClr val="accent2"/>
-                </a:fillRef>
-                <a:effectRef idx="2">
-                  <a:schemeClr val="accent2"/>
-                </a:effectRef>
-                <a:fontRef idx="minor">
-                  <a:schemeClr val="tx1"/>
-                </a:fontRef>
-              </p:style>
-            </p:cxnSp>
-            <p:cxnSp>
-              <p:nvCxnSpPr>
-                <p:cNvPr id="105" name="Connector: Curved 104">
-                  <a:extLst>
-                    <a:ext uri="{FF2B5EF4-FFF2-40B4-BE49-F238E27FC236}">
-                      <a16:creationId xmlns:a16="http://schemas.microsoft.com/office/drawing/2014/main" id="{09528B6D-8DE4-6E3F-5D7A-3A5B4737B2D2}"/>
-                    </a:ext>
-                  </a:extLst>
-                </p:cNvPr>
-                <p:cNvCxnSpPr>
-                  <a:stCxn id="25" idx="0"/>
-                  <a:endCxn id="54" idx="0"/>
-                </p:cNvCxnSpPr>
-                <p:nvPr/>
-              </p:nvCxnSpPr>
-              <p:spPr>
-                <a:xfrm rot="16200000" flipH="1" flipV="1">
-                  <a:off x="1807809" y="2267018"/>
-                  <a:ext cx="20469" cy="2051788"/>
-                </a:xfrm>
-                <a:prstGeom prst="curvedConnector3">
-                  <a:avLst>
-                    <a:gd name="adj1" fmla="val -1116811"/>
-                  </a:avLst>
-                </a:prstGeom>
-                <a:ln>
-                  <a:tailEnd type="triangle"/>
-                </a:ln>
-              </p:spPr>
-              <p:style>
-                <a:lnRef idx="3">
-                  <a:schemeClr val="accent4"/>
-                </a:lnRef>
-                <a:fillRef idx="0">
-                  <a:schemeClr val="accent4"/>
-                </a:fillRef>
-                <a:effectRef idx="2">
-                  <a:schemeClr val="accent4"/>
-                </a:effectRef>
-                <a:fontRef idx="minor">
-                  <a:schemeClr val="tx1"/>
-                </a:fontRef>
-              </p:style>
-            </p:cxnSp>
-            <p:cxnSp>
-              <p:nvCxnSpPr>
-                <p:cNvPr id="107" name="Connector: Curved 106">
-                  <a:extLst>
-                    <a:ext uri="{FF2B5EF4-FFF2-40B4-BE49-F238E27FC236}">
-                      <a16:creationId xmlns:a16="http://schemas.microsoft.com/office/drawing/2014/main" id="{8B0DAAC8-93F6-32EF-14E9-2AD2823CE3A4}"/>
-                    </a:ext>
-                  </a:extLst>
-                </p:cNvPr>
-                <p:cNvCxnSpPr>
-                  <a:stCxn id="54" idx="2"/>
-                  <a:endCxn id="25" idx="2"/>
-                </p:cNvCxnSpPr>
-                <p:nvPr/>
-              </p:nvCxnSpPr>
-              <p:spPr>
-                <a:xfrm rot="5400000" flipH="1" flipV="1">
-                  <a:off x="1807809" y="3145757"/>
-                  <a:ext cx="20469" cy="2051788"/>
-                </a:xfrm>
-                <a:prstGeom prst="curvedConnector3">
-                  <a:avLst>
-                    <a:gd name="adj1" fmla="val -1116811"/>
-                  </a:avLst>
-                </a:prstGeom>
-                <a:ln>
-                  <a:tailEnd type="triangle"/>
-                </a:ln>
-              </p:spPr>
-              <p:style>
-                <a:lnRef idx="3">
-                  <a:schemeClr val="accent4"/>
-                </a:lnRef>
-                <a:fillRef idx="0">
-                  <a:schemeClr val="accent4"/>
-                </a:fillRef>
-                <a:effectRef idx="2">
-                  <a:schemeClr val="accent4"/>
-                </a:effectRef>
-                <a:fontRef idx="minor">
-                  <a:schemeClr val="tx1"/>
-                </a:fontRef>
-              </p:style>
-            </p:cxnSp>
-            <p:cxnSp>
-              <p:nvCxnSpPr>
-                <p:cNvPr id="126" name="Connector: Curved 125">
-                  <a:extLst>
-                    <a:ext uri="{FF2B5EF4-FFF2-40B4-BE49-F238E27FC236}">
-                      <a16:creationId xmlns:a16="http://schemas.microsoft.com/office/drawing/2014/main" id="{92FD11D7-D04C-2731-C33A-3E1C75E2B907}"/>
-                    </a:ext>
-                  </a:extLst>
-                </p:cNvPr>
-                <p:cNvCxnSpPr>
-                  <a:stCxn id="111" idx="0"/>
-                  <a:endCxn id="6" idx="3"/>
-                </p:cNvCxnSpPr>
-                <p:nvPr/>
-              </p:nvCxnSpPr>
-              <p:spPr>
-                <a:xfrm rot="5400000" flipH="1" flipV="1">
-                  <a:off x="7033743" y="2435095"/>
-                  <a:ext cx="837800" cy="898303"/>
-                </a:xfrm>
-                <a:prstGeom prst="curvedConnector2">
-                  <a:avLst/>
-                </a:prstGeom>
-                <a:ln>
-                  <a:tailEnd type="triangle"/>
-                </a:ln>
-              </p:spPr>
-              <p:style>
-                <a:lnRef idx="3">
-                  <a:schemeClr val="accent2"/>
-                </a:lnRef>
-                <a:fillRef idx="0">
-                  <a:schemeClr val="accent2"/>
-                </a:fillRef>
-                <a:effectRef idx="2">
-                  <a:schemeClr val="accent2"/>
-                </a:effectRef>
-                <a:fontRef idx="minor">
-                  <a:schemeClr val="tx1"/>
-                </a:fontRef>
-              </p:style>
-            </p:cxnSp>
-            <p:cxnSp>
-              <p:nvCxnSpPr>
-                <p:cNvPr id="128" name="Connector: Curved 127">
-                  <a:extLst>
-                    <a:ext uri="{FF2B5EF4-FFF2-40B4-BE49-F238E27FC236}">
-                      <a16:creationId xmlns:a16="http://schemas.microsoft.com/office/drawing/2014/main" id="{18F41E54-DDFD-62CD-5A65-2A27F6D5013F}"/>
-                    </a:ext>
-                  </a:extLst>
-                </p:cNvPr>
-                <p:cNvCxnSpPr>
-                  <a:stCxn id="7" idx="0"/>
-                  <a:endCxn id="111" idx="2"/>
-                </p:cNvCxnSpPr>
-                <p:nvPr/>
-              </p:nvCxnSpPr>
-              <p:spPr>
-                <a:xfrm rot="10800000">
-                  <a:off x="7003492" y="4181884"/>
-                  <a:ext cx="898302" cy="745020"/>
-                </a:xfrm>
-                <a:prstGeom prst="curvedConnector2">
-                  <a:avLst/>
-                </a:prstGeom>
-                <a:ln>
-                  <a:tailEnd type="triangle"/>
-                </a:ln>
-              </p:spPr>
-              <p:style>
-                <a:lnRef idx="3">
-                  <a:schemeClr val="accent2"/>
-                </a:lnRef>
-                <a:fillRef idx="0">
-                  <a:schemeClr val="accent2"/>
-                </a:fillRef>
-                <a:effectRef idx="2">
-                  <a:schemeClr val="accent2"/>
-                </a:effectRef>
-                <a:fontRef idx="minor">
-                  <a:schemeClr val="tx1"/>
-                </a:fontRef>
-              </p:style>
-            </p:cxnSp>
-            <p:sp>
-              <p:nvSpPr>
-                <p:cNvPr id="132" name="Arrow: Left-Right 131">
-                  <a:extLst>
-                    <a:ext uri="{FF2B5EF4-FFF2-40B4-BE49-F238E27FC236}">
-                      <a16:creationId xmlns:a16="http://schemas.microsoft.com/office/drawing/2014/main" id="{3469F32C-EAF8-74C6-BC2A-18B72550A539}"/>
-                    </a:ext>
-                  </a:extLst>
-                </p:cNvPr>
-                <p:cNvSpPr/>
-                <p:nvPr/>
-              </p:nvSpPr>
-              <p:spPr>
-                <a:xfrm>
-                  <a:off x="5794028" y="3709358"/>
-                  <a:ext cx="478608" cy="92015"/>
-                </a:xfrm>
-                <a:prstGeom prst="leftRightArrow">
-                  <a:avLst/>
-                </a:prstGeom>
-                <a:solidFill>
-                  <a:schemeClr val="accent4"/>
-                </a:solidFill>
-              </p:spPr>
-              <p:style>
-                <a:lnRef idx="2">
-                  <a:schemeClr val="accent2"/>
-                </a:lnRef>
-                <a:fillRef idx="1">
-                  <a:schemeClr val="lt1"/>
-                </a:fillRef>
-                <a:effectRef idx="0">
-                  <a:schemeClr val="accent2"/>
-                </a:effectRef>
-                <a:fontRef idx="minor">
-                  <a:schemeClr val="dk1"/>
-                </a:fontRef>
-              </p:style>
-              <p:txBody>
-                <a:bodyPr rtlCol="0" anchor="ctr"/>
-                <a:lstStyle/>
-                <a:p>
-                  <a:pPr algn="ctr"/>
-                  <a:endParaRPr lang="en-DK" dirty="0"/>
-                </a:p>
-              </p:txBody>
-            </p:sp>
-            <p:sp>
-              <p:nvSpPr>
-                <p:cNvPr id="166" name="Isosceles Triangle 165">
-                  <a:extLst>
-                    <a:ext uri="{FF2B5EF4-FFF2-40B4-BE49-F238E27FC236}">
-                      <a16:creationId xmlns:a16="http://schemas.microsoft.com/office/drawing/2014/main" id="{D3FD03BE-B787-B8A8-2212-3F9B24957F21}"/>
-                    </a:ext>
-                  </a:extLst>
-                </p:cNvPr>
-                <p:cNvSpPr/>
-                <p:nvPr/>
-              </p:nvSpPr>
-              <p:spPr>
-                <a:xfrm rot="5400000">
-                  <a:off x="3620254" y="4672299"/>
-                  <a:ext cx="584006" cy="509203"/>
-                </a:xfrm>
-                <a:prstGeom prst="triangle">
-                  <a:avLst/>
-                </a:prstGeom>
-              </p:spPr>
-              <p:style>
-                <a:lnRef idx="2">
-                  <a:schemeClr val="dk1"/>
-                </a:lnRef>
-                <a:fillRef idx="1">
-                  <a:schemeClr val="lt1"/>
-                </a:fillRef>
-                <a:effectRef idx="0">
-                  <a:schemeClr val="dk1"/>
-                </a:effectRef>
-                <a:fontRef idx="minor">
-                  <a:schemeClr val="dk1"/>
-                </a:fontRef>
-              </p:style>
-              <p:txBody>
-                <a:bodyPr rtlCol="0" anchor="ctr"/>
-                <a:lstStyle/>
-                <a:p>
-                  <a:pPr algn="ctr"/>
-                  <a:endParaRPr lang="en-DK"/>
-                </a:p>
-              </p:txBody>
-            </p:sp>
-            <p:sp>
-              <p:nvSpPr>
-                <p:cNvPr id="169" name="Isosceles Triangle 168">
-                  <a:extLst>
-                    <a:ext uri="{FF2B5EF4-FFF2-40B4-BE49-F238E27FC236}">
-                      <a16:creationId xmlns:a16="http://schemas.microsoft.com/office/drawing/2014/main" id="{43F8C14B-DE60-5F27-8D29-C62774FA7151}"/>
-                    </a:ext>
-                  </a:extLst>
-                </p:cNvPr>
-                <p:cNvSpPr/>
-                <p:nvPr/>
-              </p:nvSpPr>
-              <p:spPr>
-                <a:xfrm rot="16200000">
-                  <a:off x="3617079" y="2231537"/>
-                  <a:ext cx="584006" cy="509203"/>
-                </a:xfrm>
-                <a:prstGeom prst="triangle">
-                  <a:avLst/>
-                </a:prstGeom>
-              </p:spPr>
-              <p:style>
-                <a:lnRef idx="2">
-                  <a:schemeClr val="dk1"/>
-                </a:lnRef>
-                <a:fillRef idx="1">
-                  <a:schemeClr val="lt1"/>
-                </a:fillRef>
-                <a:effectRef idx="0">
-                  <a:schemeClr val="dk1"/>
-                </a:effectRef>
-                <a:fontRef idx="minor">
-                  <a:schemeClr val="dk1"/>
-                </a:fontRef>
-              </p:style>
-              <p:txBody>
-                <a:bodyPr rtlCol="0" anchor="ctr"/>
-                <a:lstStyle/>
-                <a:p>
-                  <a:pPr algn="ctr"/>
-                  <a:endParaRPr lang="en-DK" dirty="0"/>
-                </a:p>
-              </p:txBody>
-            </p:sp>
-          </p:grpSp>
-          <p:cxnSp>
-            <p:nvCxnSpPr>
-              <p:cNvPr id="137" name="Connector: Curved 136">
-                <a:extLst>
-                  <a:ext uri="{FF2B5EF4-FFF2-40B4-BE49-F238E27FC236}">
-                    <a16:creationId xmlns:a16="http://schemas.microsoft.com/office/drawing/2014/main" id="{40D65F85-F15F-DA78-652A-D568732B2590}"/>
-                  </a:ext>
-                </a:extLst>
-              </p:cNvPr>
-              <p:cNvCxnSpPr>
-                <a:cxnSpLocks/>
-                <a:stCxn id="24" idx="0"/>
-              </p:cNvCxnSpPr>
-              <p:nvPr/>
-            </p:nvCxnSpPr>
-            <p:spPr>
-              <a:xfrm rot="5400000" flipH="1" flipV="1">
-                <a:off x="10650550" y="2399947"/>
-                <a:ext cx="361087" cy="1019538"/>
-              </a:xfrm>
-              <a:prstGeom prst="curvedConnector2">
-                <a:avLst/>
-              </a:prstGeom>
-              <a:ln>
-                <a:tailEnd type="triangle"/>
-              </a:ln>
-            </p:spPr>
-            <p:style>
-              <a:lnRef idx="3">
-                <a:schemeClr val="accent2"/>
-              </a:lnRef>
-              <a:fillRef idx="0">
-                <a:schemeClr val="accent2"/>
-              </a:fillRef>
-              <a:effectRef idx="2">
-                <a:schemeClr val="accent2"/>
-              </a:effectRef>
-              <a:fontRef idx="minor">
-                <a:schemeClr val="tx1"/>
-              </a:fontRef>
-            </p:style>
-          </p:cxnSp>
-          <p:cxnSp>
-            <p:nvCxnSpPr>
-              <p:cNvPr id="140" name="Connector: Curved 139">
-                <a:extLst>
-                  <a:ext uri="{FF2B5EF4-FFF2-40B4-BE49-F238E27FC236}">
-                    <a16:creationId xmlns:a16="http://schemas.microsoft.com/office/drawing/2014/main" id="{8B0CC4CE-67D3-0A47-76D8-6E2B2E54F4EF}"/>
-                  </a:ext>
-                </a:extLst>
-              </p:cNvPr>
-              <p:cNvCxnSpPr>
-                <a:cxnSpLocks/>
-                <a:endCxn id="24" idx="2"/>
-              </p:cNvCxnSpPr>
-              <p:nvPr/>
-            </p:nvCxnSpPr>
-            <p:spPr>
-              <a:xfrm rot="10800000">
-                <a:off x="10321324" y="3847719"/>
-                <a:ext cx="1019536" cy="321097"/>
-              </a:xfrm>
-              <a:prstGeom prst="curvedConnector2">
-                <a:avLst/>
-              </a:prstGeom>
-              <a:ln>
-                <a:tailEnd type="triangle"/>
-              </a:ln>
-            </p:spPr>
-            <p:style>
-              <a:lnRef idx="3">
-                <a:schemeClr val="accent2"/>
-              </a:lnRef>
-              <a:fillRef idx="0">
-                <a:schemeClr val="accent2"/>
-              </a:fillRef>
-              <a:effectRef idx="2">
-                <a:schemeClr val="accent2"/>
-              </a:effectRef>
-              <a:fontRef idx="minor">
-                <a:schemeClr val="tx1"/>
-              </a:fontRef>
-            </p:style>
-          </p:cxnSp>
-          <p:cxnSp>
-            <p:nvCxnSpPr>
-              <p:cNvPr id="151" name="Connector: Curved 150">
-                <a:extLst>
-                  <a:ext uri="{FF2B5EF4-FFF2-40B4-BE49-F238E27FC236}">
-                    <a16:creationId xmlns:a16="http://schemas.microsoft.com/office/drawing/2014/main" id="{1EC051D2-1A9B-15C4-E2BB-B3B84FDEAF61}"/>
-                  </a:ext>
-                </a:extLst>
-              </p:cNvPr>
-              <p:cNvCxnSpPr>
-                <a:cxnSpLocks/>
-                <a:stCxn id="54" idx="0"/>
-              </p:cNvCxnSpPr>
-              <p:nvPr/>
-            </p:nvCxnSpPr>
-            <p:spPr>
-              <a:xfrm rot="16200000" flipV="1">
-                <a:off x="1168484" y="2388066"/>
-                <a:ext cx="361087" cy="1043300"/>
-              </a:xfrm>
-              <a:prstGeom prst="curvedConnector2">
-                <a:avLst/>
-              </a:prstGeom>
-              <a:ln>
-                <a:tailEnd type="triangle"/>
-              </a:ln>
-            </p:spPr>
-            <p:style>
-              <a:lnRef idx="3">
-                <a:schemeClr val="accent4"/>
-              </a:lnRef>
-              <a:fillRef idx="0">
-                <a:schemeClr val="accent4"/>
-              </a:fillRef>
-              <a:effectRef idx="2">
-                <a:schemeClr val="accent4"/>
-              </a:effectRef>
-              <a:fontRef idx="minor">
-                <a:schemeClr val="tx1"/>
-              </a:fontRef>
-            </p:style>
-          </p:cxnSp>
-          <p:cxnSp>
-            <p:nvCxnSpPr>
-              <p:cNvPr id="153" name="Connector: Curved 152">
-                <a:extLst>
-                  <a:ext uri="{FF2B5EF4-FFF2-40B4-BE49-F238E27FC236}">
-                    <a16:creationId xmlns:a16="http://schemas.microsoft.com/office/drawing/2014/main" id="{83D77EE4-DFD9-A016-238B-67777944B90B}"/>
-                  </a:ext>
-                </a:extLst>
-              </p:cNvPr>
-              <p:cNvCxnSpPr>
-                <a:cxnSpLocks/>
-                <a:endCxn id="54" idx="2"/>
-              </p:cNvCxnSpPr>
-              <p:nvPr/>
-            </p:nvCxnSpPr>
-            <p:spPr>
-              <a:xfrm flipV="1">
-                <a:off x="870969" y="3847718"/>
-                <a:ext cx="999708" cy="390492"/>
-              </a:xfrm>
-              <a:prstGeom prst="curvedConnector2">
-                <a:avLst/>
-              </a:prstGeom>
-              <a:ln>
-                <a:tailEnd type="triangle"/>
-              </a:ln>
-            </p:spPr>
-            <p:style>
-              <a:lnRef idx="3">
-                <a:schemeClr val="accent4"/>
-              </a:lnRef>
-              <a:fillRef idx="0">
-                <a:schemeClr val="accent4"/>
-              </a:fillRef>
-              <a:effectRef idx="2">
-                <a:schemeClr val="accent4"/>
-              </a:effectRef>
-              <a:fontRef idx="minor">
-                <a:schemeClr val="tx1"/>
-              </a:fontRef>
-            </p:style>
-          </p:cxnSp>
-          <p:sp>
-            <p:nvSpPr>
-              <p:cNvPr id="158" name="TextBox 157">
-                <a:extLst>
-                  <a:ext uri="{FF2B5EF4-FFF2-40B4-BE49-F238E27FC236}">
-                    <a16:creationId xmlns:a16="http://schemas.microsoft.com/office/drawing/2014/main" id="{4582A449-4888-087B-10EC-E8CAACDB267C}"/>
-                  </a:ext>
-                </a:extLst>
-              </p:cNvPr>
-              <p:cNvSpPr txBox="1"/>
-              <p:nvPr/>
-            </p:nvSpPr>
-            <p:spPr>
-              <a:xfrm rot="16200000">
-                <a:off x="-166230" y="3275110"/>
-                <a:ext cx="1163780" cy="307777"/>
-              </a:xfrm>
-              <a:prstGeom prst="rect">
-                <a:avLst/>
-              </a:prstGeom>
-              <a:noFill/>
-              <a:ln>
-                <a:solidFill>
-                  <a:schemeClr val="accent4"/>
-                </a:solidFill>
-              </a:ln>
-            </p:spPr>
-            <p:txBody>
-              <a:bodyPr wrap="none" rtlCol="0">
-                <a:spAutoFit/>
-              </a:bodyPr>
-              <a:lstStyle/>
-              <a:p>
-                <a:r>
-                  <a:rPr lang="en-GB" sz="1400" dirty="0"/>
-                  <a:t>Water chiller</a:t>
-                </a:r>
-                <a:endParaRPr lang="en-DK" sz="1400" dirty="0"/>
-              </a:p>
-            </p:txBody>
-          </p:sp>
-          <p:sp>
-            <p:nvSpPr>
-              <p:cNvPr id="159" name="TextBox 158">
-                <a:extLst>
-                  <a:ext uri="{FF2B5EF4-FFF2-40B4-BE49-F238E27FC236}">
-                    <a16:creationId xmlns:a16="http://schemas.microsoft.com/office/drawing/2014/main" id="{1ECBC63F-6461-2AAE-2A47-D0C3AE6DB577}"/>
-                  </a:ext>
-                </a:extLst>
-              </p:cNvPr>
-              <p:cNvSpPr txBox="1"/>
-              <p:nvPr/>
-            </p:nvSpPr>
-            <p:spPr>
-              <a:xfrm rot="5400000">
-                <a:off x="10896002" y="3326176"/>
-                <a:ext cx="1576778" cy="307777"/>
-              </a:xfrm>
-              <a:prstGeom prst="rect">
-                <a:avLst/>
-              </a:prstGeom>
-              <a:noFill/>
-              <a:ln>
-                <a:solidFill>
-                  <a:schemeClr val="accent2"/>
-                </a:solidFill>
-              </a:ln>
-            </p:spPr>
-            <p:txBody>
-              <a:bodyPr wrap="none" rtlCol="0">
-                <a:spAutoFit/>
-              </a:bodyPr>
-              <a:lstStyle/>
-              <a:p>
-                <a:r>
-                  <a:rPr lang="en-GB" sz="1400" dirty="0"/>
-                  <a:t>Heat to consumer</a:t>
-                </a:r>
-                <a:endParaRPr lang="en-DK" sz="1400" dirty="0"/>
-              </a:p>
-            </p:txBody>
-          </p:sp>
-          <p:sp>
-            <p:nvSpPr>
-              <p:cNvPr id="162" name="TextBox 161">
-                <a:extLst>
-                  <a:ext uri="{FF2B5EF4-FFF2-40B4-BE49-F238E27FC236}">
-                    <a16:creationId xmlns:a16="http://schemas.microsoft.com/office/drawing/2014/main" id="{DCC2C8D1-F33F-CE04-C68F-68947F062974}"/>
-                  </a:ext>
-                </a:extLst>
-              </p:cNvPr>
-              <p:cNvSpPr txBox="1"/>
-              <p:nvPr/>
-            </p:nvSpPr>
-            <p:spPr>
-              <a:xfrm>
-                <a:off x="5798180" y="2672626"/>
-                <a:ext cx="560538" cy="307777"/>
-              </a:xfrm>
-              <a:prstGeom prst="rect">
-                <a:avLst/>
-              </a:prstGeom>
-              <a:noFill/>
-            </p:spPr>
-            <p:txBody>
-              <a:bodyPr wrap="none" rtlCol="0">
-                <a:spAutoFit/>
-              </a:bodyPr>
-              <a:lstStyle/>
-              <a:p>
-                <a:r>
-                  <a:rPr lang="en-GB" sz="1400" dirty="0"/>
-                  <a:t>Core</a:t>
-                </a:r>
-                <a:endParaRPr lang="en-DK" sz="1400" dirty="0"/>
-              </a:p>
-            </p:txBody>
-          </p:sp>
-          <mc:AlternateContent xmlns:mc="http://schemas.openxmlformats.org/markup-compatibility/2006">
-            <mc:Choice xmlns:a14="http://schemas.microsoft.com/office/drawing/2010/main" Requires="a14">
-              <p:sp>
-                <p:nvSpPr>
-                  <p:cNvPr id="163" name="TextBox 162">
-                    <a:extLst>
-                      <a:ext uri="{FF2B5EF4-FFF2-40B4-BE49-F238E27FC236}">
-                        <a16:creationId xmlns:a16="http://schemas.microsoft.com/office/drawing/2014/main" id="{BCBFEE1B-4640-C28E-E5D4-02F9564952D3}"/>
-                      </a:ext>
-                    </a:extLst>
-                  </p:cNvPr>
-                  <p:cNvSpPr txBox="1"/>
-                  <p:nvPr/>
-                </p:nvSpPr>
-                <p:spPr>
-                  <a:xfrm>
-                    <a:off x="7517383" y="2145773"/>
-                    <a:ext cx="411588" cy="369332"/>
-                  </a:xfrm>
-                  <a:prstGeom prst="rect">
-                    <a:avLst/>
-                  </a:prstGeom>
-                  <a:noFill/>
-                </p:spPr>
-                <p:txBody>
-                  <a:bodyPr wrap="none" rtlCol="0">
-                    <a:spAutoFit/>
-                  </a:bodyPr>
-                  <a:lstStyle/>
-                  <a:p>
-                    <a14:m>
-                      <m:oMathPara xmlns:m="http://schemas.openxmlformats.org/officeDocument/2006/math">
-                        <m:oMathParaPr>
-                          <m:jc m:val="centerGroup"/>
-                        </m:oMathParaPr>
-                        <m:oMath xmlns:m="http://schemas.openxmlformats.org/officeDocument/2006/math">
-                          <m:sSub>
-                            <m:sSubPr>
-                              <m:ctrlPr>
-                                <a:rPr lang="en-GB" b="0" i="1" smtClean="0">
-                                  <a:latin typeface="Cambria Math" panose="02040503050406030204" pitchFamily="18" charset="0"/>
-                                </a:rPr>
-                              </m:ctrlPr>
-                            </m:sSubPr>
-                            <m:e>
-                              <m:r>
-                                <a:rPr lang="en-GB" b="0" i="1" smtClean="0">
-                                  <a:latin typeface="Cambria Math" panose="02040503050406030204" pitchFamily="18" charset="0"/>
-                                </a:rPr>
-                                <m:t>𝜏</m:t>
-                              </m:r>
-                            </m:e>
-                            <m:sub>
-                              <m:r>
-                                <a:rPr lang="en-GB" b="0" i="1" smtClean="0">
-                                  <a:latin typeface="Cambria Math" panose="02040503050406030204" pitchFamily="18" charset="0"/>
-                                </a:rPr>
-                                <m:t>𝑙</m:t>
-                              </m:r>
-                            </m:sub>
-                          </m:sSub>
-                        </m:oMath>
-                      </m:oMathPara>
-                    </a14:m>
-                    <a:endParaRPr lang="en-DK" dirty="0"/>
-                  </a:p>
-                </p:txBody>
-              </p:sp>
-            </mc:Choice>
-            <mc:Fallback>
-              <p:sp>
-                <p:nvSpPr>
-                  <p:cNvPr id="163" name="TextBox 162">
-                    <a:extLst>
-                      <a:ext uri="{FF2B5EF4-FFF2-40B4-BE49-F238E27FC236}">
-                        <a16:creationId xmlns:a16="http://schemas.microsoft.com/office/drawing/2014/main" id="{BCBFEE1B-4640-C28E-E5D4-02F9564952D3}"/>
-                      </a:ext>
-                    </a:extLst>
-                  </p:cNvPr>
-                  <p:cNvSpPr txBox="1">
-                    <a:spLocks noRot="1" noChangeAspect="1" noMove="1" noResize="1" noEditPoints="1" noAdjustHandles="1" noChangeArrowheads="1" noChangeShapeType="1" noTextEdit="1"/>
-                  </p:cNvSpPr>
-                  <p:nvPr/>
-                </p:nvSpPr>
-                <p:spPr>
-                  <a:xfrm>
-                    <a:off x="7517383" y="2145773"/>
-                    <a:ext cx="411588" cy="369332"/>
-                  </a:xfrm>
-                  <a:prstGeom prst="rect">
-                    <a:avLst/>
-                  </a:prstGeom>
-                  <a:blipFill>
-                    <a:blip r:embed="rId3"/>
-                    <a:stretch>
-                      <a:fillRect/>
-                    </a:stretch>
-                  </a:blipFill>
-                </p:spPr>
-                <p:txBody>
-                  <a:bodyPr/>
-                  <a:lstStyle/>
-                  <a:p>
-                    <a:r>
-                      <a:rPr lang="en-DK">
-                        <a:noFill/>
-                      </a:rPr>
-                      <a:t> </a:t>
-                    </a:r>
-                  </a:p>
-                </p:txBody>
-              </p:sp>
-            </mc:Fallback>
-          </mc:AlternateContent>
-          <mc:AlternateContent xmlns:mc="http://schemas.openxmlformats.org/markup-compatibility/2006">
-            <mc:Choice xmlns:a14="http://schemas.microsoft.com/office/drawing/2010/main" Requires="a14">
-              <p:sp>
-                <p:nvSpPr>
-                  <p:cNvPr id="164" name="TextBox 163">
-                    <a:extLst>
-                      <a:ext uri="{FF2B5EF4-FFF2-40B4-BE49-F238E27FC236}">
-                        <a16:creationId xmlns:a16="http://schemas.microsoft.com/office/drawing/2014/main" id="{0DDDC372-56D0-F733-35EE-8A8318D98F7D}"/>
-                      </a:ext>
-                    </a:extLst>
-                  </p:cNvPr>
-                  <p:cNvSpPr txBox="1"/>
-                  <p:nvPr/>
-                </p:nvSpPr>
-                <p:spPr>
-                  <a:xfrm>
-                    <a:off x="7673940" y="4268454"/>
-                    <a:ext cx="411588" cy="369332"/>
-                  </a:xfrm>
-                  <a:prstGeom prst="rect">
-                    <a:avLst/>
-                  </a:prstGeom>
-                  <a:noFill/>
-                </p:spPr>
-                <p:txBody>
-                  <a:bodyPr wrap="none" rtlCol="0">
-                    <a:spAutoFit/>
-                  </a:bodyPr>
-                  <a:lstStyle/>
-                  <a:p>
-                    <a14:m>
-                      <m:oMathPara xmlns:m="http://schemas.openxmlformats.org/officeDocument/2006/math">
-                        <m:oMathParaPr>
-                          <m:jc m:val="centerGroup"/>
-                        </m:oMathParaPr>
-                        <m:oMath xmlns:m="http://schemas.openxmlformats.org/officeDocument/2006/math">
-                          <m:sSub>
-                            <m:sSubPr>
-                              <m:ctrlPr>
-                                <a:rPr lang="en-GB" b="0" i="1" smtClean="0">
-                                  <a:latin typeface="Cambria Math" panose="02040503050406030204" pitchFamily="18" charset="0"/>
-                                </a:rPr>
-                              </m:ctrlPr>
-                            </m:sSubPr>
-                            <m:e>
-                              <m:r>
-                                <a:rPr lang="en-GB" b="0" i="1" smtClean="0">
-                                  <a:latin typeface="Cambria Math" panose="02040503050406030204" pitchFamily="18" charset="0"/>
-                                </a:rPr>
-                                <m:t>𝜏</m:t>
-                              </m:r>
-                            </m:e>
-                            <m:sub>
-                              <m:r>
-                                <a:rPr lang="en-GB" b="0" i="1" smtClean="0">
-                                  <a:latin typeface="Cambria Math" panose="02040503050406030204" pitchFamily="18" charset="0"/>
-                                </a:rPr>
-                                <m:t>𝑙</m:t>
-                              </m:r>
-                            </m:sub>
-                          </m:sSub>
-                        </m:oMath>
-                      </m:oMathPara>
-                    </a14:m>
-                    <a:endParaRPr lang="en-DK" dirty="0"/>
-                  </a:p>
-                </p:txBody>
-              </p:sp>
-            </mc:Choice>
-            <mc:Fallback>
-              <p:sp>
-                <p:nvSpPr>
-                  <p:cNvPr id="164" name="TextBox 163">
-                    <a:extLst>
-                      <a:ext uri="{FF2B5EF4-FFF2-40B4-BE49-F238E27FC236}">
-                        <a16:creationId xmlns:a16="http://schemas.microsoft.com/office/drawing/2014/main" id="{0DDDC372-56D0-F733-35EE-8A8318D98F7D}"/>
-                      </a:ext>
-                    </a:extLst>
-                  </p:cNvPr>
-                  <p:cNvSpPr txBox="1">
-                    <a:spLocks noRot="1" noChangeAspect="1" noMove="1" noResize="1" noEditPoints="1" noAdjustHandles="1" noChangeArrowheads="1" noChangeShapeType="1" noTextEdit="1"/>
-                  </p:cNvSpPr>
-                  <p:nvPr/>
-                </p:nvSpPr>
-                <p:spPr>
-                  <a:xfrm>
-                    <a:off x="7673940" y="4268454"/>
-                    <a:ext cx="411588" cy="369332"/>
-                  </a:xfrm>
-                  <a:prstGeom prst="rect">
-                    <a:avLst/>
-                  </a:prstGeom>
-                  <a:blipFill>
-                    <a:blip r:embed="rId4"/>
-                    <a:stretch>
-                      <a:fillRect/>
-                    </a:stretch>
-                  </a:blipFill>
-                </p:spPr>
-                <p:txBody>
-                  <a:bodyPr/>
-                  <a:lstStyle/>
-                  <a:p>
-                    <a:r>
-                      <a:rPr lang="en-DK">
-                        <a:noFill/>
-                      </a:rPr>
-                      <a:t> </a:t>
-                    </a:r>
-                  </a:p>
-                </p:txBody>
-              </p:sp>
-            </mc:Fallback>
-          </mc:AlternateContent>
-          <mc:AlternateContent xmlns:mc="http://schemas.openxmlformats.org/markup-compatibility/2006">
-            <mc:Choice xmlns:a14="http://schemas.microsoft.com/office/drawing/2010/main" Requires="a14">
-              <p:sp>
-                <p:nvSpPr>
-                  <p:cNvPr id="165" name="TextBox 164">
-                    <a:extLst>
-                      <a:ext uri="{FF2B5EF4-FFF2-40B4-BE49-F238E27FC236}">
-                        <a16:creationId xmlns:a16="http://schemas.microsoft.com/office/drawing/2014/main" id="{626CA88C-7FEB-F802-78AF-2F47DF9600E9}"/>
-                      </a:ext>
-                    </a:extLst>
-                  </p:cNvPr>
-                  <p:cNvSpPr txBox="1"/>
-                  <p:nvPr/>
-                </p:nvSpPr>
-                <p:spPr>
-                  <a:xfrm>
-                    <a:off x="4154074" y="4246431"/>
-                    <a:ext cx="258669" cy="369332"/>
-                  </a:xfrm>
-                  <a:prstGeom prst="rect">
-                    <a:avLst/>
-                  </a:prstGeom>
-                  <a:noFill/>
-                </p:spPr>
-                <p:txBody>
-                  <a:bodyPr wrap="square" rtlCol="0">
-                    <a:spAutoFit/>
-                  </a:bodyPr>
-                  <a:lstStyle/>
-                  <a:p>
-                    <a14:m>
-                      <m:oMathPara xmlns:m="http://schemas.openxmlformats.org/officeDocument/2006/math">
-                        <m:oMathParaPr>
-                          <m:jc m:val="centerGroup"/>
-                        </m:oMathParaPr>
-                        <m:oMath xmlns:m="http://schemas.openxmlformats.org/officeDocument/2006/math">
-                          <m:sSub>
-                            <m:sSubPr>
-                              <m:ctrlPr>
-                                <a:rPr lang="en-GB" b="0" i="1" smtClean="0">
-                                  <a:latin typeface="Cambria Math" panose="02040503050406030204" pitchFamily="18" charset="0"/>
-                                </a:rPr>
-                              </m:ctrlPr>
-                            </m:sSubPr>
-                            <m:e>
-                              <m:r>
-                                <a:rPr lang="en-GB" b="0" i="1" smtClean="0">
-                                  <a:latin typeface="Cambria Math" panose="02040503050406030204" pitchFamily="18" charset="0"/>
-                                </a:rPr>
-                                <m:t>𝜏</m:t>
-                              </m:r>
-                            </m:e>
-                            <m:sub>
-                              <m:r>
-                                <a:rPr lang="en-GB" b="0" i="1" smtClean="0">
-                                  <a:latin typeface="Cambria Math" panose="02040503050406030204" pitchFamily="18" charset="0"/>
-                                </a:rPr>
-                                <m:t>𝑙</m:t>
-                              </m:r>
-                            </m:sub>
-                          </m:sSub>
-                        </m:oMath>
-                      </m:oMathPara>
-                    </a14:m>
-                    <a:endParaRPr lang="en-DK" dirty="0"/>
-                  </a:p>
-                </p:txBody>
-              </p:sp>
-            </mc:Choice>
-            <mc:Fallback>
-              <p:sp>
-                <p:nvSpPr>
-                  <p:cNvPr id="165" name="TextBox 164">
-                    <a:extLst>
-                      <a:ext uri="{FF2B5EF4-FFF2-40B4-BE49-F238E27FC236}">
-                        <a16:creationId xmlns:a16="http://schemas.microsoft.com/office/drawing/2014/main" id="{626CA88C-7FEB-F802-78AF-2F47DF9600E9}"/>
-                      </a:ext>
-                    </a:extLst>
-                  </p:cNvPr>
-                  <p:cNvSpPr txBox="1">
-                    <a:spLocks noRot="1" noChangeAspect="1" noMove="1" noResize="1" noEditPoints="1" noAdjustHandles="1" noChangeArrowheads="1" noChangeShapeType="1" noTextEdit="1"/>
-                  </p:cNvSpPr>
-                  <p:nvPr/>
-                </p:nvSpPr>
-                <p:spPr>
-                  <a:xfrm>
-                    <a:off x="4154074" y="4246431"/>
-                    <a:ext cx="258669" cy="369332"/>
-                  </a:xfrm>
-                  <a:prstGeom prst="rect">
-                    <a:avLst/>
-                  </a:prstGeom>
-                  <a:blipFill>
-                    <a:blip r:embed="rId5"/>
-                    <a:stretch>
-                      <a:fillRect r="-20930"/>
-                    </a:stretch>
-                  </a:blipFill>
-                </p:spPr>
-                <p:txBody>
-                  <a:bodyPr/>
-                  <a:lstStyle/>
-                  <a:p>
-                    <a:r>
-                      <a:rPr lang="en-DK">
-                        <a:noFill/>
-                      </a:rPr>
-                      <a:t> </a:t>
-                    </a:r>
-                  </a:p>
-                </p:txBody>
-              </p:sp>
-            </mc:Fallback>
-          </mc:AlternateContent>
-          <mc:AlternateContent xmlns:mc="http://schemas.openxmlformats.org/markup-compatibility/2006">
-            <mc:Choice xmlns:a14="http://schemas.microsoft.com/office/drawing/2010/main" Requires="a14">
-              <p:sp>
-                <p:nvSpPr>
-                  <p:cNvPr id="170" name="TextBox 169">
-                    <a:extLst>
-                      <a:ext uri="{FF2B5EF4-FFF2-40B4-BE49-F238E27FC236}">
-                        <a16:creationId xmlns:a16="http://schemas.microsoft.com/office/drawing/2014/main" id="{85E8C84A-6AE7-4576-D472-7309B0675042}"/>
-                      </a:ext>
-                    </a:extLst>
-                  </p:cNvPr>
-                  <p:cNvSpPr txBox="1"/>
-                  <p:nvPr/>
-                </p:nvSpPr>
-                <p:spPr>
-                  <a:xfrm>
-                    <a:off x="4291040" y="2183420"/>
-                    <a:ext cx="258669" cy="369332"/>
-                  </a:xfrm>
-                  <a:prstGeom prst="rect">
-                    <a:avLst/>
-                  </a:prstGeom>
-                  <a:noFill/>
-                </p:spPr>
-                <p:txBody>
-                  <a:bodyPr wrap="square" rtlCol="0">
-                    <a:spAutoFit/>
-                  </a:bodyPr>
-                  <a:lstStyle/>
-                  <a:p>
-                    <a14:m>
-                      <m:oMathPara xmlns:m="http://schemas.openxmlformats.org/officeDocument/2006/math">
-                        <m:oMathParaPr>
-                          <m:jc m:val="centerGroup"/>
-                        </m:oMathParaPr>
-                        <m:oMath xmlns:m="http://schemas.openxmlformats.org/officeDocument/2006/math">
-                          <m:sSub>
-                            <m:sSubPr>
-                              <m:ctrlPr>
-                                <a:rPr lang="en-GB" b="0" i="1" smtClean="0">
-                                  <a:latin typeface="Cambria Math" panose="02040503050406030204" pitchFamily="18" charset="0"/>
-                                </a:rPr>
-                              </m:ctrlPr>
-                            </m:sSubPr>
-                            <m:e>
-                              <m:r>
-                                <a:rPr lang="en-GB" b="0" i="1" smtClean="0">
-                                  <a:latin typeface="Cambria Math" panose="02040503050406030204" pitchFamily="18" charset="0"/>
-                                </a:rPr>
-                                <m:t>𝜏</m:t>
-                              </m:r>
-                            </m:e>
-                            <m:sub>
-                              <m:r>
-                                <a:rPr lang="en-GB" b="0" i="1" smtClean="0">
-                                  <a:latin typeface="Cambria Math" panose="02040503050406030204" pitchFamily="18" charset="0"/>
-                                </a:rPr>
-                                <m:t>𝑙</m:t>
-                              </m:r>
-                            </m:sub>
-                          </m:sSub>
-                        </m:oMath>
-                      </m:oMathPara>
-                    </a14:m>
-                    <a:endParaRPr lang="en-DK" dirty="0"/>
-                  </a:p>
-                </p:txBody>
-              </p:sp>
-            </mc:Choice>
-            <mc:Fallback>
-              <p:sp>
-                <p:nvSpPr>
-                  <p:cNvPr id="170" name="TextBox 169">
-                    <a:extLst>
-                      <a:ext uri="{FF2B5EF4-FFF2-40B4-BE49-F238E27FC236}">
-                        <a16:creationId xmlns:a16="http://schemas.microsoft.com/office/drawing/2014/main" id="{85E8C84A-6AE7-4576-D472-7309B0675042}"/>
-                      </a:ext>
-                    </a:extLst>
-                  </p:cNvPr>
-                  <p:cNvSpPr txBox="1">
-                    <a:spLocks noRot="1" noChangeAspect="1" noMove="1" noResize="1" noEditPoints="1" noAdjustHandles="1" noChangeArrowheads="1" noChangeShapeType="1" noTextEdit="1"/>
-                  </p:cNvSpPr>
-                  <p:nvPr/>
-                </p:nvSpPr>
-                <p:spPr>
-                  <a:xfrm>
-                    <a:off x="4291040" y="2183420"/>
-                    <a:ext cx="258669" cy="369332"/>
-                  </a:xfrm>
-                  <a:prstGeom prst="rect">
-                    <a:avLst/>
-                  </a:prstGeom>
-                  <a:blipFill>
-                    <a:blip r:embed="rId6"/>
-                    <a:stretch>
-                      <a:fillRect r="-21429"/>
-                    </a:stretch>
-                  </a:blipFill>
-                </p:spPr>
-                <p:txBody>
-                  <a:bodyPr/>
-                  <a:lstStyle/>
-                  <a:p>
-                    <a:r>
-                      <a:rPr lang="en-DK">
-                        <a:noFill/>
-                      </a:rPr>
-                      <a:t> </a:t>
-                    </a:r>
-                  </a:p>
-                </p:txBody>
-              </p:sp>
-            </mc:Fallback>
-          </mc:AlternateContent>
-        </p:grpSp>
+            <a:prstGeom prst="roundRect">
+              <a:avLst/>
+            </a:prstGeom>
+          </p:spPr>
+          <p:style>
+            <a:lnRef idx="1">
+              <a:schemeClr val="dk1"/>
+            </a:lnRef>
+            <a:fillRef idx="2">
+              <a:schemeClr val="dk1"/>
+            </a:fillRef>
+            <a:effectRef idx="1">
+              <a:schemeClr val="dk1"/>
+            </a:effectRef>
+            <a:fontRef idx="minor">
+              <a:schemeClr val="dk1"/>
+            </a:fontRef>
+          </p:style>
+          <p:txBody>
+            <a:bodyPr rtlCol="0" anchor="ctr"/>
+            <a:lstStyle/>
+            <a:p>
+              <a:pPr algn="ctr"/>
+              <a:endParaRPr lang="en-DK"/>
+            </a:p>
+          </p:txBody>
+        </p:sp>
+        <p:sp>
+          <p:nvSpPr>
+            <p:cNvPr id="4" name="Rectangle: Rounded Corners 3">
+              <a:extLst>
+                <a:ext uri="{FF2B5EF4-FFF2-40B4-BE49-F238E27FC236}">
+                  <a16:creationId xmlns:a16="http://schemas.microsoft.com/office/drawing/2014/main" id="{6814767B-0783-F40C-C088-0D3F8E6482AE}"/>
+                </a:ext>
+              </a:extLst>
+            </p:cNvPr>
+            <p:cNvSpPr/>
+            <p:nvPr/>
+          </p:nvSpPr>
+          <p:spPr>
+            <a:xfrm>
+              <a:off x="4724680" y="3095733"/>
+              <a:ext cx="1178399" cy="757459"/>
+            </a:xfrm>
+            <a:prstGeom prst="roundRect">
+              <a:avLst/>
+            </a:prstGeom>
+          </p:spPr>
+          <p:style>
+            <a:lnRef idx="1">
+              <a:schemeClr val="accent4"/>
+            </a:lnRef>
+            <a:fillRef idx="2">
+              <a:schemeClr val="accent4"/>
+            </a:fillRef>
+            <a:effectRef idx="1">
+              <a:schemeClr val="accent4"/>
+            </a:effectRef>
+            <a:fontRef idx="minor">
+              <a:schemeClr val="dk1"/>
+            </a:fontRef>
+          </p:style>
+          <p:txBody>
+            <a:bodyPr rtlCol="0" anchor="ctr"/>
+            <a:lstStyle/>
+            <a:p>
+              <a:pPr algn="ctr"/>
+              <a:r>
+                <a:rPr lang="en-GB" sz="1400" dirty="0"/>
+                <a:t>Core,  Heavy Water</a:t>
+              </a:r>
+              <a:endParaRPr lang="en-DK" sz="1400" dirty="0"/>
+            </a:p>
+          </p:txBody>
+        </p:sp>
+        <p:sp>
+          <p:nvSpPr>
+            <p:cNvPr id="5" name="Rectangle: Rounded Corners 4">
+              <a:extLst>
+                <a:ext uri="{FF2B5EF4-FFF2-40B4-BE49-F238E27FC236}">
+                  <a16:creationId xmlns:a16="http://schemas.microsoft.com/office/drawing/2014/main" id="{F0D813E4-EC22-E518-18EB-5E5DE4C554F8}"/>
+                </a:ext>
+              </a:extLst>
+            </p:cNvPr>
+            <p:cNvSpPr/>
+            <p:nvPr/>
+          </p:nvSpPr>
+          <p:spPr>
+            <a:xfrm>
+              <a:off x="8078020" y="3090259"/>
+              <a:ext cx="1178399" cy="757459"/>
+            </a:xfrm>
+            <a:prstGeom prst="roundRect">
+              <a:avLst/>
+            </a:prstGeom>
+          </p:spPr>
+          <p:style>
+            <a:lnRef idx="1">
+              <a:schemeClr val="accent2"/>
+            </a:lnRef>
+            <a:fillRef idx="2">
+              <a:schemeClr val="accent2"/>
+            </a:fillRef>
+            <a:effectRef idx="1">
+              <a:schemeClr val="accent2"/>
+            </a:effectRef>
+            <a:fontRef idx="minor">
+              <a:schemeClr val="dk1"/>
+            </a:fontRef>
+          </p:style>
+          <p:txBody>
+            <a:bodyPr rtlCol="0" anchor="ctr"/>
+            <a:lstStyle/>
+            <a:p>
+              <a:pPr algn="ctr"/>
+              <a:r>
+                <a:rPr lang="en-GB" sz="1400" dirty="0"/>
+                <a:t>Heat Exchanger</a:t>
+              </a:r>
+              <a:endParaRPr lang="en-DK" sz="1400" dirty="0"/>
+            </a:p>
+          </p:txBody>
+        </p:sp>
+        <p:sp>
+          <p:nvSpPr>
+            <p:cNvPr id="6" name="Isosceles Triangle 5">
+              <a:extLst>
+                <a:ext uri="{FF2B5EF4-FFF2-40B4-BE49-F238E27FC236}">
+                  <a16:creationId xmlns:a16="http://schemas.microsoft.com/office/drawing/2014/main" id="{A2BCEB2F-12D8-D5B4-1834-87486F885E98}"/>
+                </a:ext>
+              </a:extLst>
+            </p:cNvPr>
+            <p:cNvSpPr/>
+            <p:nvPr/>
+          </p:nvSpPr>
+          <p:spPr>
+            <a:xfrm rot="5400000">
+              <a:off x="7389875" y="2157358"/>
+              <a:ext cx="503405" cy="410508"/>
+            </a:xfrm>
+            <a:prstGeom prst="triangle">
+              <a:avLst/>
+            </a:prstGeom>
+          </p:spPr>
+          <p:style>
+            <a:lnRef idx="2">
+              <a:schemeClr val="dk1"/>
+            </a:lnRef>
+            <a:fillRef idx="1">
+              <a:schemeClr val="lt1"/>
+            </a:fillRef>
+            <a:effectRef idx="0">
+              <a:schemeClr val="dk1"/>
+            </a:effectRef>
+            <a:fontRef idx="minor">
+              <a:schemeClr val="dk1"/>
+            </a:fontRef>
+          </p:style>
+          <p:txBody>
+            <a:bodyPr rtlCol="0" anchor="ctr"/>
+            <a:lstStyle/>
+            <a:p>
+              <a:pPr algn="ctr"/>
+              <a:endParaRPr lang="en-DK" dirty="0"/>
+            </a:p>
+          </p:txBody>
+        </p:sp>
+        <p:sp>
+          <p:nvSpPr>
+            <p:cNvPr id="7" name="Isosceles Triangle 6">
+              <a:extLst>
+                <a:ext uri="{FF2B5EF4-FFF2-40B4-BE49-F238E27FC236}">
+                  <a16:creationId xmlns:a16="http://schemas.microsoft.com/office/drawing/2014/main" id="{C5D8EAD3-B018-605A-1B0C-E2218D1A91B2}"/>
+                </a:ext>
+              </a:extLst>
+            </p:cNvPr>
+            <p:cNvSpPr/>
+            <p:nvPr/>
+          </p:nvSpPr>
+          <p:spPr>
+            <a:xfrm rot="16200000">
+              <a:off x="7381662" y="4290132"/>
+              <a:ext cx="503405" cy="410508"/>
+            </a:xfrm>
+            <a:prstGeom prst="triangle">
+              <a:avLst/>
+            </a:prstGeom>
+          </p:spPr>
+          <p:style>
+            <a:lnRef idx="2">
+              <a:schemeClr val="dk1"/>
+            </a:lnRef>
+            <a:fillRef idx="1">
+              <a:schemeClr val="lt1"/>
+            </a:fillRef>
+            <a:effectRef idx="0">
+              <a:schemeClr val="dk1"/>
+            </a:effectRef>
+            <a:fontRef idx="minor">
+              <a:schemeClr val="dk1"/>
+            </a:fontRef>
+          </p:style>
+          <p:txBody>
+            <a:bodyPr rtlCol="0" anchor="ctr"/>
+            <a:lstStyle/>
+            <a:p>
+              <a:pPr algn="ctr"/>
+              <a:endParaRPr lang="en-DK"/>
+            </a:p>
+          </p:txBody>
+        </p:sp>
+        <p:sp>
+          <p:nvSpPr>
+            <p:cNvPr id="24" name="Rectangle: Rounded Corners 23">
+              <a:extLst>
+                <a:ext uri="{FF2B5EF4-FFF2-40B4-BE49-F238E27FC236}">
+                  <a16:creationId xmlns:a16="http://schemas.microsoft.com/office/drawing/2014/main" id="{B9CC57FA-F63C-464C-AC90-408AD39B565A}"/>
+                </a:ext>
+              </a:extLst>
+            </p:cNvPr>
+            <p:cNvSpPr/>
+            <p:nvPr/>
+          </p:nvSpPr>
+          <p:spPr>
+            <a:xfrm>
+              <a:off x="9732124" y="3090259"/>
+              <a:ext cx="1178399" cy="757459"/>
+            </a:xfrm>
+            <a:prstGeom prst="roundRect">
+              <a:avLst/>
+            </a:prstGeom>
+            <a:effectLst/>
+          </p:spPr>
+          <p:style>
+            <a:lnRef idx="1">
+              <a:schemeClr val="accent2"/>
+            </a:lnRef>
+            <a:fillRef idx="2">
+              <a:schemeClr val="accent2"/>
+            </a:fillRef>
+            <a:effectRef idx="1">
+              <a:schemeClr val="accent2"/>
+            </a:effectRef>
+            <a:fontRef idx="minor">
+              <a:schemeClr val="dk1"/>
+            </a:fontRef>
+          </p:style>
+          <p:txBody>
+            <a:bodyPr rtlCol="0" anchor="ctr"/>
+            <a:lstStyle/>
+            <a:p>
+              <a:pPr algn="ctr"/>
+              <a:r>
+                <a:rPr lang="en-GB" sz="1400" dirty="0"/>
+                <a:t>Helium Coolant</a:t>
+              </a:r>
+              <a:endParaRPr lang="en-DK" sz="1400" dirty="0"/>
+            </a:p>
+          </p:txBody>
+        </p:sp>
+        <p:sp>
+          <p:nvSpPr>
+            <p:cNvPr id="25" name="Rectangle: Rounded Corners 24">
+              <a:extLst>
+                <a:ext uri="{FF2B5EF4-FFF2-40B4-BE49-F238E27FC236}">
+                  <a16:creationId xmlns:a16="http://schemas.microsoft.com/office/drawing/2014/main" id="{4D832E5E-136E-5381-B4A6-510DCE1FEF0C}"/>
+                </a:ext>
+              </a:extLst>
+            </p:cNvPr>
+            <p:cNvSpPr/>
+            <p:nvPr/>
+          </p:nvSpPr>
+          <p:spPr>
+            <a:xfrm>
+              <a:off x="2935583" y="3072615"/>
+              <a:ext cx="1178399" cy="757459"/>
+            </a:xfrm>
+            <a:prstGeom prst="roundRect">
+              <a:avLst/>
+            </a:prstGeom>
+          </p:spPr>
+          <p:style>
+            <a:lnRef idx="1">
+              <a:schemeClr val="accent4"/>
+            </a:lnRef>
+            <a:fillRef idx="2">
+              <a:schemeClr val="accent4"/>
+            </a:fillRef>
+            <a:effectRef idx="1">
+              <a:schemeClr val="accent4"/>
+            </a:effectRef>
+            <a:fontRef idx="minor">
+              <a:schemeClr val="dk1"/>
+            </a:fontRef>
+          </p:style>
+          <p:txBody>
+            <a:bodyPr rtlCol="0" anchor="ctr"/>
+            <a:lstStyle/>
+            <a:p>
+              <a:pPr algn="ctr"/>
+              <a:r>
+                <a:rPr lang="en-GB" sz="1400" dirty="0"/>
+                <a:t>Heat Exchanger</a:t>
+              </a:r>
+              <a:endParaRPr lang="en-DK" sz="1400" dirty="0"/>
+            </a:p>
+          </p:txBody>
+        </p:sp>
+        <p:sp>
+          <p:nvSpPr>
+            <p:cNvPr id="54" name="Rectangle: Rounded Corners 53">
+              <a:extLst>
+                <a:ext uri="{FF2B5EF4-FFF2-40B4-BE49-F238E27FC236}">
+                  <a16:creationId xmlns:a16="http://schemas.microsoft.com/office/drawing/2014/main" id="{DFFE57D5-58A5-4A89-EFB5-F0F4C179224D}"/>
+                </a:ext>
+              </a:extLst>
+            </p:cNvPr>
+            <p:cNvSpPr/>
+            <p:nvPr/>
+          </p:nvSpPr>
+          <p:spPr>
+            <a:xfrm>
+              <a:off x="1281477" y="3090259"/>
+              <a:ext cx="1178399" cy="757459"/>
+            </a:xfrm>
+            <a:prstGeom prst="roundRect">
+              <a:avLst/>
+            </a:prstGeom>
+          </p:spPr>
+          <p:style>
+            <a:lnRef idx="1">
+              <a:schemeClr val="accent4"/>
+            </a:lnRef>
+            <a:fillRef idx="2">
+              <a:schemeClr val="accent4"/>
+            </a:fillRef>
+            <a:effectRef idx="1">
+              <a:schemeClr val="accent4"/>
+            </a:effectRef>
+            <a:fontRef idx="minor">
+              <a:schemeClr val="dk1"/>
+            </a:fontRef>
+          </p:style>
+          <p:txBody>
+            <a:bodyPr rtlCol="0" anchor="ctr"/>
+            <a:lstStyle/>
+            <a:p>
+              <a:pPr algn="ctr"/>
+              <a:r>
+                <a:rPr lang="en-GB" sz="1400" dirty="0">
+                  <a:cs typeface="Aldhabi" panose="01000000000000000000" pitchFamily="2" charset="-78"/>
+                </a:rPr>
+                <a:t>Light Water Coolant</a:t>
+              </a:r>
+              <a:endParaRPr lang="en-DK" sz="1400" dirty="0">
+                <a:cs typeface="Aldhabi" panose="01000000000000000000" pitchFamily="2" charset="-78"/>
+              </a:endParaRPr>
+            </a:p>
+          </p:txBody>
+        </p:sp>
+        <p:sp>
+          <p:nvSpPr>
+            <p:cNvPr id="111" name="Rectangle: Rounded Corners 110">
+              <a:extLst>
+                <a:ext uri="{FF2B5EF4-FFF2-40B4-BE49-F238E27FC236}">
+                  <a16:creationId xmlns:a16="http://schemas.microsoft.com/office/drawing/2014/main" id="{2D86E45E-E479-1CC8-4526-F561E796C416}"/>
+                </a:ext>
+              </a:extLst>
+            </p:cNvPr>
+            <p:cNvSpPr/>
+            <p:nvPr/>
+          </p:nvSpPr>
+          <p:spPr>
+            <a:xfrm>
+              <a:off x="6288922" y="3090258"/>
+              <a:ext cx="1178399" cy="757459"/>
+            </a:xfrm>
+            <a:prstGeom prst="roundRect">
+              <a:avLst/>
+            </a:prstGeom>
+          </p:spPr>
+          <p:style>
+            <a:lnRef idx="1">
+              <a:schemeClr val="accent2"/>
+            </a:lnRef>
+            <a:fillRef idx="2">
+              <a:schemeClr val="accent2"/>
+            </a:fillRef>
+            <a:effectRef idx="1">
+              <a:schemeClr val="accent2"/>
+            </a:effectRef>
+            <a:fontRef idx="minor">
+              <a:schemeClr val="dk1"/>
+            </a:fontRef>
+          </p:style>
+          <p:txBody>
+            <a:bodyPr rtlCol="0" anchor="ctr"/>
+            <a:lstStyle/>
+            <a:p>
+              <a:pPr algn="ctr"/>
+              <a:r>
+                <a:rPr lang="en-GB" sz="1400" dirty="0"/>
+                <a:t>Core, Fuel</a:t>
+              </a:r>
+              <a:endParaRPr lang="en-DK" sz="1400" dirty="0"/>
+            </a:p>
+          </p:txBody>
+        </p:sp>
         <p:cxnSp>
           <p:nvCxnSpPr>
-            <p:cNvPr id="174" name="Connector: Curved 173">
+            <p:cNvPr id="91" name="Connector: Curved 90">
               <a:extLst>
                 <a:ext uri="{FF2B5EF4-FFF2-40B4-BE49-F238E27FC236}">
-                  <a16:creationId xmlns:a16="http://schemas.microsoft.com/office/drawing/2014/main" id="{B7BFDD0F-7086-183A-DAB7-9D73635F9DA3}"/>
+                  <a16:creationId xmlns:a16="http://schemas.microsoft.com/office/drawing/2014/main" id="{E48BAD00-07BD-7CEF-CDC4-E4096CB492A6}"/>
                 </a:ext>
               </a:extLst>
             </p:cNvPr>
             <p:cNvCxnSpPr>
-              <a:stCxn id="169" idx="0"/>
-              <a:endCxn id="25" idx="0"/>
+              <a:cxnSpLocks/>
+              <a:stCxn id="6" idx="0"/>
             </p:cNvCxnSpPr>
             <p:nvPr/>
           </p:nvCxnSpPr>
           <p:spPr>
-            <a:xfrm rot="10800000" flipV="1">
-              <a:off x="3524784" y="2386009"/>
-              <a:ext cx="653441" cy="686606"/>
+            <a:xfrm>
+              <a:off x="7846832" y="2362612"/>
+              <a:ext cx="654398" cy="722172"/>
             </a:xfrm>
             <a:prstGeom prst="curvedConnector2">
               <a:avLst/>
+            </a:prstGeom>
+            <a:ln>
+              <a:tailEnd type="triangle"/>
+            </a:ln>
+          </p:spPr>
+          <p:style>
+            <a:lnRef idx="3">
+              <a:schemeClr val="accent2"/>
+            </a:lnRef>
+            <a:fillRef idx="0">
+              <a:schemeClr val="accent2"/>
+            </a:fillRef>
+            <a:effectRef idx="2">
+              <a:schemeClr val="accent2"/>
+            </a:effectRef>
+            <a:fontRef idx="minor">
+              <a:schemeClr val="tx1"/>
+            </a:fontRef>
+          </p:style>
+        </p:cxnSp>
+        <p:cxnSp>
+          <p:nvCxnSpPr>
+            <p:cNvPr id="93" name="Connector: Curved 92">
+              <a:extLst>
+                <a:ext uri="{FF2B5EF4-FFF2-40B4-BE49-F238E27FC236}">
+                  <a16:creationId xmlns:a16="http://schemas.microsoft.com/office/drawing/2014/main" id="{116D635F-2556-2A47-9979-A6346FDDEBDB}"/>
+                </a:ext>
+              </a:extLst>
+            </p:cNvPr>
+            <p:cNvCxnSpPr>
+              <a:cxnSpLocks/>
+              <a:endCxn id="7" idx="3"/>
+            </p:cNvCxnSpPr>
+            <p:nvPr/>
+          </p:nvCxnSpPr>
+          <p:spPr>
+            <a:xfrm rot="5400000">
+              <a:off x="7844721" y="3847089"/>
+              <a:ext cx="642196" cy="654399"/>
+            </a:xfrm>
+            <a:prstGeom prst="curvedConnector2">
+              <a:avLst/>
+            </a:prstGeom>
+            <a:ln>
+              <a:tailEnd type="triangle"/>
+            </a:ln>
+          </p:spPr>
+          <p:style>
+            <a:lnRef idx="3">
+              <a:schemeClr val="accent2"/>
+            </a:lnRef>
+            <a:fillRef idx="0">
+              <a:schemeClr val="accent2"/>
+            </a:fillRef>
+            <a:effectRef idx="2">
+              <a:schemeClr val="accent2"/>
+            </a:effectRef>
+            <a:fontRef idx="minor">
+              <a:schemeClr val="tx1"/>
+            </a:fontRef>
+          </p:style>
+        </p:cxnSp>
+        <p:cxnSp>
+          <p:nvCxnSpPr>
+            <p:cNvPr id="97" name="Connector: Curved 96">
+              <a:extLst>
+                <a:ext uri="{FF2B5EF4-FFF2-40B4-BE49-F238E27FC236}">
+                  <a16:creationId xmlns:a16="http://schemas.microsoft.com/office/drawing/2014/main" id="{6F7C95D4-84FA-3A61-189E-F624859D4D19}"/>
+                </a:ext>
+              </a:extLst>
+            </p:cNvPr>
+            <p:cNvCxnSpPr>
+              <a:stCxn id="5" idx="0"/>
+              <a:endCxn id="24" idx="0"/>
+            </p:cNvCxnSpPr>
+            <p:nvPr/>
+          </p:nvCxnSpPr>
+          <p:spPr>
+            <a:xfrm rot="5400000" flipH="1" flipV="1">
+              <a:off x="9493917" y="2263207"/>
+              <a:ext cx="10947" cy="1654105"/>
+            </a:xfrm>
+            <a:prstGeom prst="curvedConnector3">
+              <a:avLst>
+                <a:gd name="adj1" fmla="val 1800000"/>
+              </a:avLst>
+            </a:prstGeom>
+            <a:ln>
+              <a:tailEnd type="triangle"/>
+            </a:ln>
+          </p:spPr>
+          <p:style>
+            <a:lnRef idx="3">
+              <a:schemeClr val="accent2"/>
+            </a:lnRef>
+            <a:fillRef idx="0">
+              <a:schemeClr val="accent2"/>
+            </a:fillRef>
+            <a:effectRef idx="2">
+              <a:schemeClr val="accent2"/>
+            </a:effectRef>
+            <a:fontRef idx="minor">
+              <a:schemeClr val="tx1"/>
+            </a:fontRef>
+          </p:style>
+        </p:cxnSp>
+        <p:cxnSp>
+          <p:nvCxnSpPr>
+            <p:cNvPr id="99" name="Connector: Curved 98">
+              <a:extLst>
+                <a:ext uri="{FF2B5EF4-FFF2-40B4-BE49-F238E27FC236}">
+                  <a16:creationId xmlns:a16="http://schemas.microsoft.com/office/drawing/2014/main" id="{59A45D60-C73F-77B9-350D-DF2241CF00C4}"/>
+                </a:ext>
+              </a:extLst>
+            </p:cNvPr>
+            <p:cNvCxnSpPr>
+              <a:stCxn id="24" idx="2"/>
+              <a:endCxn id="5" idx="2"/>
+            </p:cNvCxnSpPr>
+            <p:nvPr/>
+          </p:nvCxnSpPr>
+          <p:spPr>
+            <a:xfrm rot="5400000">
+              <a:off x="9493918" y="3020666"/>
+              <a:ext cx="10947" cy="1654105"/>
+            </a:xfrm>
+            <a:prstGeom prst="curvedConnector3">
+              <a:avLst>
+                <a:gd name="adj1" fmla="val 1800000"/>
+              </a:avLst>
+            </a:prstGeom>
+            <a:ln>
+              <a:tailEnd type="triangle"/>
+            </a:ln>
+          </p:spPr>
+          <p:style>
+            <a:lnRef idx="3">
+              <a:schemeClr val="accent2"/>
+            </a:lnRef>
+            <a:fillRef idx="0">
+              <a:schemeClr val="accent2"/>
+            </a:fillRef>
+            <a:effectRef idx="2">
+              <a:schemeClr val="accent2"/>
+            </a:effectRef>
+            <a:fontRef idx="minor">
+              <a:schemeClr val="tx1"/>
+            </a:fontRef>
+          </p:style>
+        </p:cxnSp>
+        <p:cxnSp>
+          <p:nvCxnSpPr>
+            <p:cNvPr id="105" name="Connector: Curved 104">
+              <a:extLst>
+                <a:ext uri="{FF2B5EF4-FFF2-40B4-BE49-F238E27FC236}">
+                  <a16:creationId xmlns:a16="http://schemas.microsoft.com/office/drawing/2014/main" id="{09528B6D-8DE4-6E3F-5D7A-3A5B4737B2D2}"/>
+                </a:ext>
+              </a:extLst>
+            </p:cNvPr>
+            <p:cNvCxnSpPr>
+              <a:cxnSpLocks/>
+            </p:cNvCxnSpPr>
+            <p:nvPr/>
+          </p:nvCxnSpPr>
+          <p:spPr>
+            <a:xfrm rot="16200000" flipH="1" flipV="1">
+              <a:off x="2540918" y="2254384"/>
+              <a:ext cx="17644" cy="1654106"/>
+            </a:xfrm>
+            <a:prstGeom prst="curvedConnector3">
+              <a:avLst>
+                <a:gd name="adj1" fmla="val -1116811"/>
+              </a:avLst>
             </a:prstGeom>
             <a:ln>
               <a:tailEnd type="triangle"/>
@@ -6184,26 +4795,27 @@
         </p:cxnSp>
         <p:cxnSp>
           <p:nvCxnSpPr>
-            <p:cNvPr id="178" name="Connector: Curved 177">
+            <p:cNvPr id="107" name="Connector: Curved 106">
               <a:extLst>
                 <a:ext uri="{FF2B5EF4-FFF2-40B4-BE49-F238E27FC236}">
-                  <a16:creationId xmlns:a16="http://schemas.microsoft.com/office/drawing/2014/main" id="{E2AFF61A-6168-8EC2-797E-76804261AE05}"/>
+                  <a16:creationId xmlns:a16="http://schemas.microsoft.com/office/drawing/2014/main" id="{8B0DAAC8-93F6-32EF-14E9-2AD2823CE3A4}"/>
                 </a:ext>
               </a:extLst>
             </p:cNvPr>
             <p:cNvCxnSpPr>
-              <a:stCxn id="166" idx="0"/>
-              <a:endCxn id="4" idx="2"/>
+              <a:cxnSpLocks/>
             </p:cNvCxnSpPr>
             <p:nvPr/>
           </p:nvCxnSpPr>
           <p:spPr>
-            <a:xfrm flipV="1">
-              <a:off x="4591292" y="3853192"/>
-              <a:ext cx="722588" cy="636720"/>
+            <a:xfrm rot="5400000" flipH="1" flipV="1">
+              <a:off x="2540918" y="3011843"/>
+              <a:ext cx="17644" cy="1654106"/>
             </a:xfrm>
-            <a:prstGeom prst="curvedConnector2">
-              <a:avLst/>
+            <a:prstGeom prst="curvedConnector3">
+              <a:avLst>
+                <a:gd name="adj1" fmla="val -1116811"/>
+              </a:avLst>
             </a:prstGeom>
             <a:ln>
               <a:tailEnd type="triangle"/>
@@ -6226,26 +4838,422 @@
         </p:cxnSp>
         <p:cxnSp>
           <p:nvCxnSpPr>
-            <p:cNvPr id="187" name="Connector: Curved 186">
+            <p:cNvPr id="126" name="Connector: Curved 125">
               <a:extLst>
                 <a:ext uri="{FF2B5EF4-FFF2-40B4-BE49-F238E27FC236}">
-                  <a16:creationId xmlns:a16="http://schemas.microsoft.com/office/drawing/2014/main" id="{8B84FD31-98BE-6E29-07F3-6F78702A468F}"/>
+                  <a16:creationId xmlns:a16="http://schemas.microsoft.com/office/drawing/2014/main" id="{92FD11D7-D04C-2731-C33A-3E1C75E2B907}"/>
                 </a:ext>
               </a:extLst>
             </p:cNvPr>
             <p:cNvCxnSpPr>
-              <a:stCxn id="4" idx="0"/>
-              <a:endCxn id="169" idx="3"/>
+              <a:cxnSpLocks/>
+              <a:endCxn id="6" idx="3"/>
             </p:cNvCxnSpPr>
             <p:nvPr/>
           </p:nvCxnSpPr>
           <p:spPr>
-            <a:xfrm rot="16200000" flipV="1">
-              <a:off x="4596444" y="2378297"/>
-              <a:ext cx="709724" cy="725148"/>
+            <a:xfrm rot="5400000" flipH="1" flipV="1">
+              <a:off x="6713141" y="2361603"/>
+              <a:ext cx="722171" cy="724192"/>
             </a:xfrm>
             <a:prstGeom prst="curvedConnector2">
               <a:avLst/>
+            </a:prstGeom>
+            <a:ln>
+              <a:tailEnd type="triangle"/>
+            </a:ln>
+          </p:spPr>
+          <p:style>
+            <a:lnRef idx="3">
+              <a:schemeClr val="accent2"/>
+            </a:lnRef>
+            <a:fillRef idx="0">
+              <a:schemeClr val="accent2"/>
+            </a:fillRef>
+            <a:effectRef idx="2">
+              <a:schemeClr val="accent2"/>
+            </a:effectRef>
+            <a:fontRef idx="minor">
+              <a:schemeClr val="tx1"/>
+            </a:fontRef>
+          </p:style>
+        </p:cxnSp>
+        <p:cxnSp>
+          <p:nvCxnSpPr>
+            <p:cNvPr id="128" name="Connector: Curved 127">
+              <a:extLst>
+                <a:ext uri="{FF2B5EF4-FFF2-40B4-BE49-F238E27FC236}">
+                  <a16:creationId xmlns:a16="http://schemas.microsoft.com/office/drawing/2014/main" id="{18F41E54-DDFD-62CD-5A65-2A27F6D5013F}"/>
+                </a:ext>
+              </a:extLst>
+            </p:cNvPr>
+            <p:cNvCxnSpPr>
+              <a:cxnSpLocks/>
+              <a:stCxn id="7" idx="0"/>
+            </p:cNvCxnSpPr>
+            <p:nvPr/>
+          </p:nvCxnSpPr>
+          <p:spPr>
+            <a:xfrm rot="10800000">
+              <a:off x="6703920" y="3853190"/>
+              <a:ext cx="724191" cy="642196"/>
+            </a:xfrm>
+            <a:prstGeom prst="curvedConnector2">
+              <a:avLst/>
+            </a:prstGeom>
+            <a:ln>
+              <a:tailEnd type="triangle"/>
+            </a:ln>
+          </p:spPr>
+          <p:style>
+            <a:lnRef idx="3">
+              <a:schemeClr val="accent2"/>
+            </a:lnRef>
+            <a:fillRef idx="0">
+              <a:schemeClr val="accent2"/>
+            </a:fillRef>
+            <a:effectRef idx="2">
+              <a:schemeClr val="accent2"/>
+            </a:effectRef>
+            <a:fontRef idx="minor">
+              <a:schemeClr val="tx1"/>
+            </a:fontRef>
+          </p:style>
+        </p:cxnSp>
+        <p:sp>
+          <p:nvSpPr>
+            <p:cNvPr id="132" name="Arrow: Left-Right 131">
+              <a:extLst>
+                <a:ext uri="{FF2B5EF4-FFF2-40B4-BE49-F238E27FC236}">
+                  <a16:creationId xmlns:a16="http://schemas.microsoft.com/office/drawing/2014/main" id="{3469F32C-EAF8-74C6-BC2A-18B72550A539}"/>
+                </a:ext>
+              </a:extLst>
+            </p:cNvPr>
+            <p:cNvSpPr/>
+            <p:nvPr/>
+          </p:nvSpPr>
+          <p:spPr>
+            <a:xfrm>
+              <a:off x="5903079" y="3440407"/>
+              <a:ext cx="385843" cy="79316"/>
+            </a:xfrm>
+            <a:prstGeom prst="leftRightArrow">
+              <a:avLst/>
+            </a:prstGeom>
+            <a:solidFill>
+              <a:schemeClr val="accent4"/>
+            </a:solidFill>
+          </p:spPr>
+          <p:style>
+            <a:lnRef idx="2">
+              <a:schemeClr val="accent2"/>
+            </a:lnRef>
+            <a:fillRef idx="1">
+              <a:schemeClr val="lt1"/>
+            </a:fillRef>
+            <a:effectRef idx="0">
+              <a:schemeClr val="accent2"/>
+            </a:effectRef>
+            <a:fontRef idx="minor">
+              <a:schemeClr val="dk1"/>
+            </a:fontRef>
+          </p:style>
+          <p:txBody>
+            <a:bodyPr rtlCol="0" anchor="ctr"/>
+            <a:lstStyle/>
+            <a:p>
+              <a:pPr algn="ctr"/>
+              <a:endParaRPr lang="en-DK" dirty="0"/>
+            </a:p>
+          </p:txBody>
+        </p:sp>
+        <p:sp>
+          <p:nvSpPr>
+            <p:cNvPr id="162" name="TextBox 161">
+              <a:extLst>
+                <a:ext uri="{FF2B5EF4-FFF2-40B4-BE49-F238E27FC236}">
+                  <a16:creationId xmlns:a16="http://schemas.microsoft.com/office/drawing/2014/main" id="{DCC2C8D1-F33F-CE04-C68F-68947F062974}"/>
+                </a:ext>
+              </a:extLst>
+            </p:cNvPr>
+            <p:cNvSpPr txBox="1"/>
+            <p:nvPr/>
+          </p:nvSpPr>
+          <p:spPr>
+            <a:xfrm>
+              <a:off x="5798180" y="2672626"/>
+              <a:ext cx="560538" cy="307777"/>
+            </a:xfrm>
+            <a:prstGeom prst="rect">
+              <a:avLst/>
+            </a:prstGeom>
+            <a:noFill/>
+          </p:spPr>
+          <p:txBody>
+            <a:bodyPr wrap="none" rtlCol="0">
+              <a:spAutoFit/>
+            </a:bodyPr>
+            <a:lstStyle/>
+            <a:p>
+              <a:r>
+                <a:rPr lang="en-GB" sz="1400" dirty="0"/>
+                <a:t>Core</a:t>
+              </a:r>
+              <a:endParaRPr lang="en-DK" sz="1400" dirty="0"/>
+            </a:p>
+          </p:txBody>
+        </p:sp>
+        <mc:AlternateContent xmlns:mc="http://schemas.openxmlformats.org/markup-compatibility/2006">
+          <mc:Choice xmlns:a14="http://schemas.microsoft.com/office/drawing/2010/main" Requires="a14">
+            <p:sp>
+              <p:nvSpPr>
+                <p:cNvPr id="163" name="TextBox 162">
+                  <a:extLst>
+                    <a:ext uri="{FF2B5EF4-FFF2-40B4-BE49-F238E27FC236}">
+                      <a16:creationId xmlns:a16="http://schemas.microsoft.com/office/drawing/2014/main" id="{BCBFEE1B-4640-C28E-E5D4-02F9564952D3}"/>
+                    </a:ext>
+                  </a:extLst>
+                </p:cNvPr>
+                <p:cNvSpPr txBox="1"/>
+                <p:nvPr/>
+              </p:nvSpPr>
+              <p:spPr>
+                <a:xfrm>
+                  <a:off x="7351393" y="2140299"/>
+                  <a:ext cx="411588" cy="369332"/>
+                </a:xfrm>
+                <a:prstGeom prst="rect">
+                  <a:avLst/>
+                </a:prstGeom>
+                <a:noFill/>
+              </p:spPr>
+              <p:txBody>
+                <a:bodyPr wrap="none" rtlCol="0">
+                  <a:spAutoFit/>
+                </a:bodyPr>
+                <a:lstStyle/>
+                <a:p>
+                  <a:pPr/>
+                  <a14:m>
+                    <m:oMathPara xmlns:m="http://schemas.openxmlformats.org/officeDocument/2006/math">
+                      <m:oMathParaPr>
+                        <m:jc m:val="centerGroup"/>
+                      </m:oMathParaPr>
+                      <m:oMath xmlns:m="http://schemas.openxmlformats.org/officeDocument/2006/math">
+                        <m:sSub>
+                          <m:sSubPr>
+                            <m:ctrlPr>
+                              <a:rPr lang="en-GB" b="0" i="1" smtClean="0">
+                                <a:latin typeface="Cambria Math" panose="02040503050406030204" pitchFamily="18" charset="0"/>
+                              </a:rPr>
+                            </m:ctrlPr>
+                          </m:sSubPr>
+                          <m:e>
+                            <m:r>
+                              <a:rPr lang="en-GB" b="0" i="1" smtClean="0">
+                                <a:latin typeface="Cambria Math" panose="02040503050406030204" pitchFamily="18" charset="0"/>
+                              </a:rPr>
+                              <m:t>𝜏</m:t>
+                            </m:r>
+                          </m:e>
+                          <m:sub>
+                            <m:r>
+                              <a:rPr lang="en-GB" b="0" i="1" smtClean="0">
+                                <a:latin typeface="Cambria Math" panose="02040503050406030204" pitchFamily="18" charset="0"/>
+                              </a:rPr>
+                              <m:t>𝑙</m:t>
+                            </m:r>
+                          </m:sub>
+                        </m:sSub>
+                      </m:oMath>
+                    </m:oMathPara>
+                  </a14:m>
+                  <a:endParaRPr lang="en-DK" dirty="0"/>
+                </a:p>
+              </p:txBody>
+            </p:sp>
+          </mc:Choice>
+          <mc:Fallback>
+            <p:sp>
+              <p:nvSpPr>
+                <p:cNvPr id="163" name="TextBox 162">
+                  <a:extLst>
+                    <a:ext uri="{FF2B5EF4-FFF2-40B4-BE49-F238E27FC236}">
+                      <a16:creationId xmlns:a16="http://schemas.microsoft.com/office/drawing/2014/main" id="{BCBFEE1B-4640-C28E-E5D4-02F9564952D3}"/>
+                    </a:ext>
+                  </a:extLst>
+                </p:cNvPr>
+                <p:cNvSpPr txBox="1">
+                  <a:spLocks noRot="1" noChangeAspect="1" noMove="1" noResize="1" noEditPoints="1" noAdjustHandles="1" noChangeArrowheads="1" noChangeShapeType="1" noTextEdit="1"/>
+                </p:cNvSpPr>
+                <p:nvPr/>
+              </p:nvSpPr>
+              <p:spPr>
+                <a:xfrm>
+                  <a:off x="7351393" y="2140299"/>
+                  <a:ext cx="411588" cy="369332"/>
+                </a:xfrm>
+                <a:prstGeom prst="rect">
+                  <a:avLst/>
+                </a:prstGeom>
+                <a:blipFill>
+                  <a:blip r:embed="rId3"/>
+                  <a:stretch>
+                    <a:fillRect/>
+                  </a:stretch>
+                </a:blipFill>
+              </p:spPr>
+              <p:txBody>
+                <a:bodyPr/>
+                <a:lstStyle/>
+                <a:p>
+                  <a:r>
+                    <a:rPr lang="en-DK">
+                      <a:noFill/>
+                    </a:rPr>
+                    <a:t> </a:t>
+                  </a:r>
+                </a:p>
+              </p:txBody>
+            </p:sp>
+          </mc:Fallback>
+        </mc:AlternateContent>
+        <mc:AlternateContent xmlns:mc="http://schemas.openxmlformats.org/markup-compatibility/2006">
+          <mc:Choice xmlns:a14="http://schemas.microsoft.com/office/drawing/2010/main" Requires="a14">
+            <p:sp>
+              <p:nvSpPr>
+                <p:cNvPr id="164" name="TextBox 163">
+                  <a:extLst>
+                    <a:ext uri="{FF2B5EF4-FFF2-40B4-BE49-F238E27FC236}">
+                      <a16:creationId xmlns:a16="http://schemas.microsoft.com/office/drawing/2014/main" id="{0DDDC372-56D0-F733-35EE-8A8318D98F7D}"/>
+                    </a:ext>
+                  </a:extLst>
+                </p:cNvPr>
+                <p:cNvSpPr txBox="1"/>
+                <p:nvPr/>
+              </p:nvSpPr>
+              <p:spPr>
+                <a:xfrm>
+                  <a:off x="7499738" y="4273927"/>
+                  <a:ext cx="411588" cy="369332"/>
+                </a:xfrm>
+                <a:prstGeom prst="rect">
+                  <a:avLst/>
+                </a:prstGeom>
+                <a:noFill/>
+              </p:spPr>
+              <p:txBody>
+                <a:bodyPr wrap="none" rtlCol="0">
+                  <a:spAutoFit/>
+                </a:bodyPr>
+                <a:lstStyle/>
+                <a:p>
+                  <a:pPr/>
+                  <a14:m>
+                    <m:oMathPara xmlns:m="http://schemas.openxmlformats.org/officeDocument/2006/math">
+                      <m:oMathParaPr>
+                        <m:jc m:val="centerGroup"/>
+                      </m:oMathParaPr>
+                      <m:oMath xmlns:m="http://schemas.openxmlformats.org/officeDocument/2006/math">
+                        <m:sSub>
+                          <m:sSubPr>
+                            <m:ctrlPr>
+                              <a:rPr lang="en-GB" b="0" i="1" smtClean="0">
+                                <a:latin typeface="Cambria Math" panose="02040503050406030204" pitchFamily="18" charset="0"/>
+                              </a:rPr>
+                            </m:ctrlPr>
+                          </m:sSubPr>
+                          <m:e>
+                            <m:r>
+                              <a:rPr lang="en-GB" b="0" i="1" smtClean="0">
+                                <a:latin typeface="Cambria Math" panose="02040503050406030204" pitchFamily="18" charset="0"/>
+                              </a:rPr>
+                              <m:t>𝜏</m:t>
+                            </m:r>
+                          </m:e>
+                          <m:sub>
+                            <m:r>
+                              <a:rPr lang="en-GB" b="0" i="1" smtClean="0">
+                                <a:latin typeface="Cambria Math" panose="02040503050406030204" pitchFamily="18" charset="0"/>
+                              </a:rPr>
+                              <m:t>𝑙</m:t>
+                            </m:r>
+                          </m:sub>
+                        </m:sSub>
+                      </m:oMath>
+                    </m:oMathPara>
+                  </a14:m>
+                  <a:endParaRPr lang="en-DK" dirty="0"/>
+                </a:p>
+              </p:txBody>
+            </p:sp>
+          </mc:Choice>
+          <mc:Fallback>
+            <p:sp>
+              <p:nvSpPr>
+                <p:cNvPr id="164" name="TextBox 163">
+                  <a:extLst>
+                    <a:ext uri="{FF2B5EF4-FFF2-40B4-BE49-F238E27FC236}">
+                      <a16:creationId xmlns:a16="http://schemas.microsoft.com/office/drawing/2014/main" id="{0DDDC372-56D0-F733-35EE-8A8318D98F7D}"/>
+                    </a:ext>
+                  </a:extLst>
+                </p:cNvPr>
+                <p:cNvSpPr txBox="1">
+                  <a:spLocks noRot="1" noChangeAspect="1" noMove="1" noResize="1" noEditPoints="1" noAdjustHandles="1" noChangeArrowheads="1" noChangeShapeType="1" noTextEdit="1"/>
+                </p:cNvSpPr>
+                <p:nvPr/>
+              </p:nvSpPr>
+              <p:spPr>
+                <a:xfrm>
+                  <a:off x="7499738" y="4273927"/>
+                  <a:ext cx="411588" cy="369332"/>
+                </a:xfrm>
+                <a:prstGeom prst="rect">
+                  <a:avLst/>
+                </a:prstGeom>
+                <a:blipFill>
+                  <a:blip r:embed="rId4"/>
+                  <a:stretch>
+                    <a:fillRect/>
+                  </a:stretch>
+                </a:blipFill>
+              </p:spPr>
+              <p:txBody>
+                <a:bodyPr/>
+                <a:lstStyle/>
+                <a:p>
+                  <a:r>
+                    <a:rPr lang="en-DK">
+                      <a:noFill/>
+                    </a:rPr>
+                    <a:t> </a:t>
+                  </a:r>
+                </a:p>
+              </p:txBody>
+            </p:sp>
+          </mc:Fallback>
+        </mc:AlternateContent>
+        <p:cxnSp>
+          <p:nvCxnSpPr>
+            <p:cNvPr id="8" name="Connector: Curved 7">
+              <a:extLst>
+                <a:ext uri="{FF2B5EF4-FFF2-40B4-BE49-F238E27FC236}">
+                  <a16:creationId xmlns:a16="http://schemas.microsoft.com/office/drawing/2014/main" id="{5E742A62-47A6-B777-AB6C-19C7AB104E93}"/>
+                </a:ext>
+              </a:extLst>
+            </p:cNvPr>
+            <p:cNvCxnSpPr/>
+            <p:nvPr/>
+          </p:nvCxnSpPr>
+          <p:spPr>
+            <a:xfrm rot="5400000" flipH="1" flipV="1">
+              <a:off x="4513164" y="3029486"/>
+              <a:ext cx="17644" cy="1654106"/>
+            </a:xfrm>
+            <a:prstGeom prst="curvedConnector3">
+              <a:avLst>
+                <a:gd name="adj1" fmla="val -3854732"/>
+              </a:avLst>
             </a:prstGeom>
             <a:ln>
               <a:tailEnd type="triangle"/>
@@ -6268,26 +5276,27 @@
         </p:cxnSp>
         <p:cxnSp>
           <p:nvCxnSpPr>
-            <p:cNvPr id="189" name="Connector: Curved 188">
+            <p:cNvPr id="9" name="Connector: Curved 8">
               <a:extLst>
                 <a:ext uri="{FF2B5EF4-FFF2-40B4-BE49-F238E27FC236}">
-                  <a16:creationId xmlns:a16="http://schemas.microsoft.com/office/drawing/2014/main" id="{8D7AD381-D604-4EA7-02BB-D2FBD222C659}"/>
+                  <a16:creationId xmlns:a16="http://schemas.microsoft.com/office/drawing/2014/main" id="{CDC24E0F-D927-84A7-3BA9-ABFFEA545859}"/>
                 </a:ext>
               </a:extLst>
             </p:cNvPr>
             <p:cNvCxnSpPr>
-              <a:stCxn id="25" idx="2"/>
-              <a:endCxn id="166" idx="3"/>
+              <a:cxnSpLocks/>
             </p:cNvCxnSpPr>
             <p:nvPr/>
           </p:nvCxnSpPr>
           <p:spPr>
-            <a:xfrm rot="16200000" flipH="1">
-              <a:off x="3522864" y="3831992"/>
-              <a:ext cx="659838" cy="656001"/>
+            <a:xfrm rot="16200000" flipH="1" flipV="1">
+              <a:off x="4480601" y="2230934"/>
+              <a:ext cx="17644" cy="1654106"/>
             </a:xfrm>
-            <a:prstGeom prst="curvedConnector2">
-              <a:avLst/>
+            <a:prstGeom prst="curvedConnector3">
+              <a:avLst>
+                <a:gd name="adj1" fmla="val -3691759"/>
+              </a:avLst>
             </a:prstGeom>
             <a:ln>
               <a:tailEnd type="triangle"/>

</xml_diff>